<commit_message>
Slides: first milestone at end of reading week, split by loop stage
Co-Authored-By: Claude Opus 5.5 (1M context) <noreply@anthropic.com>
</commit_message>
<xml_diff>
--- a/proposal/ece298a_pll_proposal_slides.pptx
+++ b/proposal/ece298a_pll_proposal_slides.pptx
@@ -7183,7 +7183,7 @@
                 </a:solidFill>
                 <a:latin typeface="Georgia"/>
               </a:rPr>
-              <a:t>Oct 8</a:t>
+              <a:t>Oct 16</a:t>
             </a:r>
           </a:p>
         </p:txBody>
@@ -7218,7 +7218,7 @@
                 </a:solidFill>
                 <a:latin typeface="Georgia"/>
               </a:rPr>
-              <a:t>Digital RTL (PFD, prescaler, divider, lock detector) and a loop model, CocoTB passing; first pump and VCO schematics</a:t>
+              <a:t>End of reading week: RTL for the PFD, prescaler, divider and lock detector with CocoTB passing; first charge pump and VCO schematics</a:t>
             </a:r>
           </a:p>
         </p:txBody>
@@ -7332,7 +7332,7 @@
                 </a:solidFill>
                 <a:latin typeface="Georgia"/>
               </a:rPr>
-              <a:t>Evaluation: pump, filter and VCO across ngspice corners; the full loop locks in simulation; loop values fixed</a:t>
+              <a:t>Evaluation: each stage simulated in ngspice; the full loop locks in simulation at the typical corner</a:t>
             </a:r>
           </a:p>
         </p:txBody>
@@ -7446,7 +7446,7 @@
                 </a:solidFill>
                 <a:latin typeface="Georgia"/>
               </a:rPr>
-              <a:t>System verification: layout DRC and LVS clean, post-layout re-simulation, Tiny Tapeout precheck green</a:t>
+              <a:t>System verification: layout DRC and LVS clean, Tiny Tapeout precheck green</a:t>
             </a:r>
           </a:p>
         </p:txBody>
@@ -7713,7 +7713,7 @@
                 </a:solidFill>
                 <a:latin typeface="Georgia"/>
               </a:rPr>
-              <a:t>ANALOG</a:t>
+              <a:t>DETECT AND FILTER</a:t>
             </a:r>
           </a:p>
         </p:txBody>
@@ -7754,7 +7754,7 @@
                 </a:solidFill>
                 <a:latin typeface="Georgia"/>
               </a:rPr>
-              <a:t>Charge pump, loop filter and VCO</a:t>
+              <a:t>PFD and charge pump</a:t>
             </a:r>
           </a:p>
           <a:p>
@@ -7772,7 +7772,7 @@
                 </a:solidFill>
                 <a:latin typeface="Georgia"/>
               </a:rPr>
-              <a:t>ngspice corner sweeps</a:t>
+              <a:t>Loop filter</a:t>
             </a:r>
           </a:p>
           <a:p>
@@ -7790,7 +7790,7 @@
                 </a:solidFill>
                 <a:latin typeface="Georgia"/>
               </a:rPr>
-              <a:t>Analog layout, DRC and LVS</a:t>
+              <a:t>Design, simulation and layout of these stages</a:t>
             </a:r>
           </a:p>
         </p:txBody>
@@ -7908,7 +7908,7 @@
                 </a:solidFill>
                 <a:latin typeface="Georgia"/>
               </a:rPr>
-              <a:t>DIGITAL</a:t>
+              <a:t>OSCILLATE AND DIVIDE</a:t>
             </a:r>
           </a:p>
         </p:txBody>
@@ -7949,7 +7949,7 @@
                 </a:solidFill>
                 <a:latin typeface="Georgia"/>
               </a:rPr>
-              <a:t>PFD, prescaler, divider, lock detector</a:t>
+              <a:t>VCO</a:t>
             </a:r>
           </a:p>
           <a:p>
@@ -7967,7 +7967,7 @@
                 </a:solidFill>
                 <a:latin typeface="Georgia"/>
               </a:rPr>
-              <a:t>CocoTB testbench and loop model</a:t>
+              <a:t>Prescaler, ÷N divider and lock detector</a:t>
             </a:r>
           </a:p>
           <a:p>
@@ -7985,7 +7985,7 @@
                 </a:solidFill>
                 <a:latin typeface="Georgia"/>
               </a:rPr>
-              <a:t>Synthesis and timing</a:t>
+              <a:t>Design, simulation and layout of these stages</a:t>
             </a:r>
           </a:p>
         </p:txBody>

</xml_diff>

<commit_message>
Slides: detailed Gantt chart for the timeline on slide 3
Co-Authored-By: Claude Opus 5.5 (1M context) <noreply@anthropic.com>
</commit_message>
<xml_diff>
--- a/proposal/ece298a_pll_proposal_slides.pptx
+++ b/proposal/ece298a_pll_proposal_slides.pptx
@@ -7041,14 +7041,58 @@
       </p:sp>
       <p:sp>
         <p:nvSpPr>
-          <p:cNvPr id="7" name="TextBox 6"/>
+          <p:cNvPr id="7" name="Rectangle 6"/>
+          <p:cNvSpPr/>
+          <p:nvPr/>
+        </p:nvSpPr>
+        <p:spPr>
+          <a:xfrm>
+            <a:off x="5337406" y="1783080"/>
+            <a:ext cx="466881" cy="2743200"/>
+          </a:xfrm>
+          <a:prstGeom prst="rect">
+            <a:avLst/>
+          </a:prstGeom>
+          <a:solidFill>
+            <a:srgbClr val="F0EADE"/>
+          </a:solidFill>
+          <a:ln>
+            <a:noFill/>
+          </a:ln>
+          <a:effectLst/>
+        </p:spPr>
+        <p:style>
+          <a:lnRef idx="1">
+            <a:schemeClr val="accent1"/>
+          </a:lnRef>
+          <a:fillRef idx="3">
+            <a:schemeClr val="accent1"/>
+          </a:fillRef>
+          <a:effectRef idx="2">
+            <a:schemeClr val="accent1"/>
+          </a:effectRef>
+          <a:fontRef idx="minor">
+            <a:schemeClr val="lt1"/>
+          </a:fontRef>
+        </p:style>
+        <p:txBody>
+          <a:bodyPr rtlCol="0" anchor="ctr"/>
+          <a:lstStyle/>
+          <a:p>
+            <a:pPr algn="ctr"/>
+          </a:p>
+        </p:txBody>
+      </p:sp>
+      <p:sp>
+        <p:nvSpPr>
+          <p:cNvPr id="8" name="TextBox 7"/>
           <p:cNvSpPr txBox="1"/>
           <p:nvPr/>
         </p:nvSpPr>
         <p:spPr>
           <a:xfrm>
-            <a:off x="548640" y="1508760"/>
-            <a:ext cx="5577840" cy="292608"/>
+            <a:off x="5063086" y="4562856"/>
+            <a:ext cx="1015521" cy="201168"/>
           </a:xfrm>
           <a:prstGeom prst="rect">
             <a:avLst/>
@@ -7061,34 +7105,113 @@
           </a:bodyPr>
           <a:lstStyle/>
           <a:p>
-            <a:pPr algn="l"/>
-            <a:r>
-              <a:rPr sz="1600" b="1" i="0">
-                <a:solidFill>
-                  <a:srgbClr val="15140F"/>
+            <a:pPr algn="ctr"/>
+            <a:r>
+              <a:rPr sz="900" b="0" i="1">
+                <a:solidFill>
+                  <a:srgbClr val="77716A"/>
                 </a:solidFill>
                 <a:latin typeface="Georgia"/>
               </a:rPr>
-              <a:t>Timeline for completion</a:t>
+              <a:t>reading week</a:t>
+            </a:r>
+          </a:p>
+        </p:txBody>
+      </p:sp>
+      <p:sp>
+        <p:nvSpPr>
+          <p:cNvPr id="9" name="Rectangle 8"/>
+          <p:cNvSpPr/>
+          <p:nvPr/>
+        </p:nvSpPr>
+        <p:spPr>
+          <a:xfrm>
+            <a:off x="6971493" y="1783080"/>
+            <a:ext cx="583602" cy="2743200"/>
+          </a:xfrm>
+          <a:prstGeom prst="rect">
+            <a:avLst/>
+          </a:prstGeom>
+          <a:solidFill>
+            <a:srgbClr val="F0EADE"/>
+          </a:solidFill>
+          <a:ln>
+            <a:noFill/>
+          </a:ln>
+          <a:effectLst/>
+        </p:spPr>
+        <p:style>
+          <a:lnRef idx="1">
+            <a:schemeClr val="accent1"/>
+          </a:lnRef>
+          <a:fillRef idx="3">
+            <a:schemeClr val="accent1"/>
+          </a:fillRef>
+          <a:effectRef idx="2">
+            <a:schemeClr val="accent1"/>
+          </a:effectRef>
+          <a:fontRef idx="minor">
+            <a:schemeClr val="lt1"/>
+          </a:fontRef>
+        </p:style>
+        <p:txBody>
+          <a:bodyPr rtlCol="0" anchor="ctr"/>
+          <a:lstStyle/>
+          <a:p>
+            <a:pPr algn="ctr"/>
+          </a:p>
+        </p:txBody>
+      </p:sp>
+      <p:sp>
+        <p:nvSpPr>
+          <p:cNvPr id="10" name="TextBox 9"/>
+          <p:cNvSpPr txBox="1"/>
+          <p:nvPr/>
+        </p:nvSpPr>
+        <p:spPr>
+          <a:xfrm>
+            <a:off x="6697173" y="4562856"/>
+            <a:ext cx="1132242" cy="201168"/>
+          </a:xfrm>
+          <a:prstGeom prst="rect">
+            <a:avLst/>
+          </a:prstGeom>
+          <a:noFill/>
+        </p:spPr>
+        <p:txBody>
+          <a:bodyPr wrap="square" lIns="0" rIns="0" tIns="0" bIns="0" anchor="t">
+            <a:spAutoFit/>
+          </a:bodyPr>
+          <a:lstStyle/>
+          <a:p>
+            <a:pPr algn="ctr"/>
+            <a:r>
+              <a:rPr sz="900" b="0" i="1">
+                <a:solidFill>
+                  <a:srgbClr val="77716A"/>
+                </a:solidFill>
+                <a:latin typeface="Georgia"/>
+              </a:rPr>
+              <a:t>midterms</a:t>
             </a:r>
           </a:p>
         </p:txBody>
       </p:sp>
       <p:cxnSp>
         <p:nvCxnSpPr>
-          <p:cNvPr id="8" name="Connector 7"/>
+          <p:cNvPr id="11" name="Connector 10"/>
           <p:cNvCxnSpPr/>
           <p:nvPr/>
         </p:nvCxnSpPr>
         <p:spPr>
           <a:xfrm>
-            <a:off x="768096" y="2148840"/>
-            <a:ext cx="0" cy="2880360"/>
+            <a:off x="3703320" y="1737360"/>
+            <a:ext cx="0" cy="2788920"/>
           </a:xfrm>
           <a:prstGeom prst="line">
             <a:avLst/>
           </a:prstGeom>
-          <a:ln w="25400">
+          <a:ln w="9525">
             <a:solidFill>
               <a:srgbClr val="DED8CA"/>
             </a:solidFill>
@@ -7111,58 +7234,14 @@
       </p:cxnSp>
       <p:sp>
         <p:nvSpPr>
-          <p:cNvPr id="9" name="Oval 8"/>
-          <p:cNvSpPr/>
-          <p:nvPr/>
-        </p:nvSpPr>
-        <p:spPr>
-          <a:xfrm>
-            <a:off x="685800" y="2066543"/>
-            <a:ext cx="164592" cy="164592"/>
-          </a:xfrm>
-          <a:prstGeom prst="ellipse">
-            <a:avLst/>
-          </a:prstGeom>
-          <a:solidFill>
-            <a:srgbClr val="9C4221"/>
-          </a:solidFill>
-          <a:ln>
-            <a:noFill/>
-          </a:ln>
-          <a:effectLst/>
-        </p:spPr>
-        <p:style>
-          <a:lnRef idx="1">
-            <a:schemeClr val="accent1"/>
-          </a:lnRef>
-          <a:fillRef idx="3">
-            <a:schemeClr val="accent1"/>
-          </a:fillRef>
-          <a:effectRef idx="2">
-            <a:schemeClr val="accent1"/>
-          </a:effectRef>
-          <a:fontRef idx="minor">
-            <a:schemeClr val="lt1"/>
-          </a:fontRef>
-        </p:style>
-        <p:txBody>
-          <a:bodyPr rtlCol="0" anchor="ctr"/>
-          <a:lstStyle/>
-          <a:p>
-            <a:pPr algn="ctr"/>
-          </a:p>
-        </p:txBody>
-      </p:sp>
-      <p:sp>
-        <p:nvSpPr>
-          <p:cNvPr id="10" name="TextBox 9"/>
+          <p:cNvPr id="12" name="TextBox 11"/>
           <p:cNvSpPr txBox="1"/>
           <p:nvPr/>
         </p:nvSpPr>
         <p:spPr>
           <a:xfrm>
-            <a:off x="1051560" y="2020824"/>
-            <a:ext cx="914400" cy="274320"/>
+            <a:off x="3739896" y="1508760"/>
+            <a:ext cx="731520" cy="201168"/>
           </a:xfrm>
           <a:prstGeom prst="rect">
             <a:avLst/>
@@ -7177,27 +7256,62 @@
           <a:p>
             <a:pPr algn="l"/>
             <a:r>
-              <a:rPr sz="1500" b="1" i="0">
-                <a:solidFill>
-                  <a:srgbClr val="9C4221"/>
+              <a:rPr sz="900" b="0" i="0">
+                <a:solidFill>
+                  <a:srgbClr val="77716A"/>
                 </a:solidFill>
                 <a:latin typeface="Georgia"/>
               </a:rPr>
-              <a:t>Oct 16</a:t>
-            </a:r>
-          </a:p>
-        </p:txBody>
-      </p:sp>
-      <p:sp>
-        <p:nvSpPr>
-          <p:cNvPr id="11" name="TextBox 10"/>
+              <a:t>Sep 28</a:t>
+            </a:r>
+          </a:p>
+        </p:txBody>
+      </p:sp>
+      <p:cxnSp>
+        <p:nvCxnSpPr>
+          <p:cNvPr id="13" name="Connector 12"/>
+          <p:cNvCxnSpPr/>
+          <p:nvPr/>
+        </p:nvCxnSpPr>
+        <p:spPr>
+          <a:xfrm>
+            <a:off x="4520363" y="1737360"/>
+            <a:ext cx="0" cy="2788920"/>
+          </a:xfrm>
+          <a:prstGeom prst="line">
+            <a:avLst/>
+          </a:prstGeom>
+          <a:ln w="9525">
+            <a:solidFill>
+              <a:srgbClr val="DED8CA"/>
+            </a:solidFill>
+          </a:ln>
+        </p:spPr>
+        <p:style>
+          <a:lnRef idx="2">
+            <a:schemeClr val="accent1"/>
+          </a:lnRef>
+          <a:fillRef idx="0">
+            <a:schemeClr val="accent1"/>
+          </a:fillRef>
+          <a:effectRef idx="1">
+            <a:schemeClr val="accent1"/>
+          </a:effectRef>
+          <a:fontRef idx="minor">
+            <a:schemeClr val="tx1"/>
+          </a:fontRef>
+        </p:style>
+      </p:cxnSp>
+      <p:sp>
+        <p:nvSpPr>
+          <p:cNvPr id="14" name="TextBox 13"/>
           <p:cNvSpPr txBox="1"/>
           <p:nvPr/>
         </p:nvSpPr>
         <p:spPr>
           <a:xfrm>
-            <a:off x="1920240" y="2029968"/>
-            <a:ext cx="4206240" cy="822960"/>
+            <a:off x="4556939" y="1508760"/>
+            <a:ext cx="731520" cy="201168"/>
           </a:xfrm>
           <a:prstGeom prst="rect">
             <a:avLst/>
@@ -7212,71 +7326,62 @@
           <a:p>
             <a:pPr algn="l"/>
             <a:r>
-              <a:rPr sz="1300" b="0" i="0">
-                <a:solidFill>
-                  <a:srgbClr val="15140F"/>
+              <a:rPr sz="900" b="0" i="0">
+                <a:solidFill>
+                  <a:srgbClr val="77716A"/>
                 </a:solidFill>
                 <a:latin typeface="Georgia"/>
               </a:rPr>
-              <a:t>End of reading week: RTL for the PFD, prescaler, divider and lock detector with CocoTB passing; first charge pump and VCO schematics</a:t>
-            </a:r>
-          </a:p>
-        </p:txBody>
-      </p:sp>
-      <p:sp>
-        <p:nvSpPr>
-          <p:cNvPr id="12" name="Oval 11"/>
-          <p:cNvSpPr/>
-          <p:nvPr/>
-        </p:nvSpPr>
-        <p:spPr>
-          <a:xfrm>
-            <a:off x="685800" y="3026663"/>
-            <a:ext cx="164592" cy="164592"/>
-          </a:xfrm>
-          <a:prstGeom prst="ellipse">
-            <a:avLst/>
-          </a:prstGeom>
-          <a:solidFill>
-            <a:srgbClr val="9C4221"/>
-          </a:solidFill>
-          <a:ln>
-            <a:noFill/>
+              <a:t>Oct 5</a:t>
+            </a:r>
+          </a:p>
+        </p:txBody>
+      </p:sp>
+      <p:cxnSp>
+        <p:nvCxnSpPr>
+          <p:cNvPr id="15" name="Connector 14"/>
+          <p:cNvCxnSpPr/>
+          <p:nvPr/>
+        </p:nvCxnSpPr>
+        <p:spPr>
+          <a:xfrm>
+            <a:off x="5337406" y="1737360"/>
+            <a:ext cx="0" cy="2788920"/>
+          </a:xfrm>
+          <a:prstGeom prst="line">
+            <a:avLst/>
+          </a:prstGeom>
+          <a:ln w="9525">
+            <a:solidFill>
+              <a:srgbClr val="DED8CA"/>
+            </a:solidFill>
           </a:ln>
-          <a:effectLst/>
         </p:spPr>
         <p:style>
-          <a:lnRef idx="1">
+          <a:lnRef idx="2">
             <a:schemeClr val="accent1"/>
           </a:lnRef>
-          <a:fillRef idx="3">
+          <a:fillRef idx="0">
             <a:schemeClr val="accent1"/>
           </a:fillRef>
-          <a:effectRef idx="2">
+          <a:effectRef idx="1">
             <a:schemeClr val="accent1"/>
           </a:effectRef>
           <a:fontRef idx="minor">
-            <a:schemeClr val="lt1"/>
+            <a:schemeClr val="tx1"/>
           </a:fontRef>
         </p:style>
-        <p:txBody>
-          <a:bodyPr rtlCol="0" anchor="ctr"/>
-          <a:lstStyle/>
-          <a:p>
-            <a:pPr algn="ctr"/>
-          </a:p>
-        </p:txBody>
-      </p:sp>
-      <p:sp>
-        <p:nvSpPr>
-          <p:cNvPr id="13" name="TextBox 12"/>
+      </p:cxnSp>
+      <p:sp>
+        <p:nvSpPr>
+          <p:cNvPr id="16" name="TextBox 15"/>
           <p:cNvSpPr txBox="1"/>
           <p:nvPr/>
         </p:nvSpPr>
         <p:spPr>
           <a:xfrm>
-            <a:off x="1051560" y="2980944"/>
-            <a:ext cx="914400" cy="274320"/>
+            <a:off x="5373982" y="1508760"/>
+            <a:ext cx="731520" cy="201168"/>
           </a:xfrm>
           <a:prstGeom prst="rect">
             <a:avLst/>
@@ -7291,27 +7396,62 @@
           <a:p>
             <a:pPr algn="l"/>
             <a:r>
-              <a:rPr sz="1500" b="1" i="0">
-                <a:solidFill>
-                  <a:srgbClr val="9C4221"/>
+              <a:rPr sz="900" b="0" i="0">
+                <a:solidFill>
+                  <a:srgbClr val="77716A"/>
                 </a:solidFill>
                 <a:latin typeface="Georgia"/>
               </a:rPr>
-              <a:t>Nov 5</a:t>
-            </a:r>
-          </a:p>
-        </p:txBody>
-      </p:sp>
-      <p:sp>
-        <p:nvSpPr>
-          <p:cNvPr id="14" name="TextBox 13"/>
+              <a:t>Oct 12</a:t>
+            </a:r>
+          </a:p>
+        </p:txBody>
+      </p:sp>
+      <p:cxnSp>
+        <p:nvCxnSpPr>
+          <p:cNvPr id="17" name="Connector 16"/>
+          <p:cNvCxnSpPr/>
+          <p:nvPr/>
+        </p:nvCxnSpPr>
+        <p:spPr>
+          <a:xfrm>
+            <a:off x="6154449" y="1737360"/>
+            <a:ext cx="0" cy="2788920"/>
+          </a:xfrm>
+          <a:prstGeom prst="line">
+            <a:avLst/>
+          </a:prstGeom>
+          <a:ln w="9525">
+            <a:solidFill>
+              <a:srgbClr val="DED8CA"/>
+            </a:solidFill>
+          </a:ln>
+        </p:spPr>
+        <p:style>
+          <a:lnRef idx="2">
+            <a:schemeClr val="accent1"/>
+          </a:lnRef>
+          <a:fillRef idx="0">
+            <a:schemeClr val="accent1"/>
+          </a:fillRef>
+          <a:effectRef idx="1">
+            <a:schemeClr val="accent1"/>
+          </a:effectRef>
+          <a:fontRef idx="minor">
+            <a:schemeClr val="tx1"/>
+          </a:fontRef>
+        </p:style>
+      </p:cxnSp>
+      <p:sp>
+        <p:nvSpPr>
+          <p:cNvPr id="18" name="TextBox 17"/>
           <p:cNvSpPr txBox="1"/>
           <p:nvPr/>
         </p:nvSpPr>
         <p:spPr>
           <a:xfrm>
-            <a:off x="1920240" y="2990088"/>
-            <a:ext cx="4206240" cy="822960"/>
+            <a:off x="6191025" y="1508760"/>
+            <a:ext cx="731520" cy="201168"/>
           </a:xfrm>
           <a:prstGeom prst="rect">
             <a:avLst/>
@@ -7326,71 +7466,62 @@
           <a:p>
             <a:pPr algn="l"/>
             <a:r>
-              <a:rPr sz="1300" b="0" i="0">
-                <a:solidFill>
-                  <a:srgbClr val="15140F"/>
+              <a:rPr sz="900" b="0" i="0">
+                <a:solidFill>
+                  <a:srgbClr val="77716A"/>
                 </a:solidFill>
                 <a:latin typeface="Georgia"/>
               </a:rPr>
-              <a:t>Evaluation: each stage simulated in ngspice; the full loop locks in simulation at the typical corner</a:t>
-            </a:r>
-          </a:p>
-        </p:txBody>
-      </p:sp>
-      <p:sp>
-        <p:nvSpPr>
-          <p:cNvPr id="15" name="Oval 14"/>
-          <p:cNvSpPr/>
-          <p:nvPr/>
-        </p:nvSpPr>
-        <p:spPr>
-          <a:xfrm>
-            <a:off x="685800" y="3986783"/>
-            <a:ext cx="164592" cy="164592"/>
-          </a:xfrm>
-          <a:prstGeom prst="ellipse">
-            <a:avLst/>
-          </a:prstGeom>
-          <a:solidFill>
-            <a:srgbClr val="9C4221"/>
-          </a:solidFill>
-          <a:ln>
-            <a:noFill/>
+              <a:t>Oct 19</a:t>
+            </a:r>
+          </a:p>
+        </p:txBody>
+      </p:sp>
+      <p:cxnSp>
+        <p:nvCxnSpPr>
+          <p:cNvPr id="19" name="Connector 18"/>
+          <p:cNvCxnSpPr/>
+          <p:nvPr/>
+        </p:nvCxnSpPr>
+        <p:spPr>
+          <a:xfrm>
+            <a:off x="6971493" y="1737360"/>
+            <a:ext cx="0" cy="2788920"/>
+          </a:xfrm>
+          <a:prstGeom prst="line">
+            <a:avLst/>
+          </a:prstGeom>
+          <a:ln w="9525">
+            <a:solidFill>
+              <a:srgbClr val="DED8CA"/>
+            </a:solidFill>
           </a:ln>
-          <a:effectLst/>
         </p:spPr>
         <p:style>
-          <a:lnRef idx="1">
+          <a:lnRef idx="2">
             <a:schemeClr val="accent1"/>
           </a:lnRef>
-          <a:fillRef idx="3">
+          <a:fillRef idx="0">
             <a:schemeClr val="accent1"/>
           </a:fillRef>
-          <a:effectRef idx="2">
+          <a:effectRef idx="1">
             <a:schemeClr val="accent1"/>
           </a:effectRef>
           <a:fontRef idx="minor">
-            <a:schemeClr val="lt1"/>
+            <a:schemeClr val="tx1"/>
           </a:fontRef>
         </p:style>
-        <p:txBody>
-          <a:bodyPr rtlCol="0" anchor="ctr"/>
-          <a:lstStyle/>
-          <a:p>
-            <a:pPr algn="ctr"/>
-          </a:p>
-        </p:txBody>
-      </p:sp>
-      <p:sp>
-        <p:nvSpPr>
-          <p:cNvPr id="16" name="TextBox 15"/>
+      </p:cxnSp>
+      <p:sp>
+        <p:nvSpPr>
+          <p:cNvPr id="20" name="TextBox 19"/>
           <p:cNvSpPr txBox="1"/>
           <p:nvPr/>
         </p:nvSpPr>
         <p:spPr>
           <a:xfrm>
-            <a:off x="1051560" y="3941063"/>
-            <a:ext cx="914400" cy="274320"/>
+            <a:off x="7008069" y="1508760"/>
+            <a:ext cx="731520" cy="201168"/>
           </a:xfrm>
           <a:prstGeom prst="rect">
             <a:avLst/>
@@ -7405,27 +7536,62 @@
           <a:p>
             <a:pPr algn="l"/>
             <a:r>
-              <a:rPr sz="1500" b="1" i="0">
-                <a:solidFill>
-                  <a:srgbClr val="9C4221"/>
+              <a:rPr sz="900" b="0" i="0">
+                <a:solidFill>
+                  <a:srgbClr val="77716A"/>
                 </a:solidFill>
                 <a:latin typeface="Georgia"/>
               </a:rPr>
-              <a:t>Nov 26</a:t>
-            </a:r>
-          </a:p>
-        </p:txBody>
-      </p:sp>
-      <p:sp>
-        <p:nvSpPr>
-          <p:cNvPr id="17" name="TextBox 16"/>
+              <a:t>Oct 26</a:t>
+            </a:r>
+          </a:p>
+        </p:txBody>
+      </p:sp>
+      <p:cxnSp>
+        <p:nvCxnSpPr>
+          <p:cNvPr id="21" name="Connector 20"/>
+          <p:cNvCxnSpPr/>
+          <p:nvPr/>
+        </p:nvCxnSpPr>
+        <p:spPr>
+          <a:xfrm>
+            <a:off x="7788536" y="1737360"/>
+            <a:ext cx="0" cy="2788920"/>
+          </a:xfrm>
+          <a:prstGeom prst="line">
+            <a:avLst/>
+          </a:prstGeom>
+          <a:ln w="9525">
+            <a:solidFill>
+              <a:srgbClr val="DED8CA"/>
+            </a:solidFill>
+          </a:ln>
+        </p:spPr>
+        <p:style>
+          <a:lnRef idx="2">
+            <a:schemeClr val="accent1"/>
+          </a:lnRef>
+          <a:fillRef idx="0">
+            <a:schemeClr val="accent1"/>
+          </a:fillRef>
+          <a:effectRef idx="1">
+            <a:schemeClr val="accent1"/>
+          </a:effectRef>
+          <a:fontRef idx="minor">
+            <a:schemeClr val="tx1"/>
+          </a:fontRef>
+        </p:style>
+      </p:cxnSp>
+      <p:sp>
+        <p:nvSpPr>
+          <p:cNvPr id="22" name="TextBox 21"/>
           <p:cNvSpPr txBox="1"/>
           <p:nvPr/>
         </p:nvSpPr>
         <p:spPr>
           <a:xfrm>
-            <a:off x="1920240" y="3950207"/>
-            <a:ext cx="4206240" cy="822960"/>
+            <a:off x="7825112" y="1508760"/>
+            <a:ext cx="731520" cy="201168"/>
           </a:xfrm>
           <a:prstGeom prst="rect">
             <a:avLst/>
@@ -7440,71 +7606,62 @@
           <a:p>
             <a:pPr algn="l"/>
             <a:r>
-              <a:rPr sz="1300" b="0" i="0">
-                <a:solidFill>
-                  <a:srgbClr val="15140F"/>
+              <a:rPr sz="900" b="0" i="0">
+                <a:solidFill>
+                  <a:srgbClr val="77716A"/>
                 </a:solidFill>
                 <a:latin typeface="Georgia"/>
               </a:rPr>
-              <a:t>System verification: layout DRC and LVS clean, Tiny Tapeout precheck green</a:t>
-            </a:r>
-          </a:p>
-        </p:txBody>
-      </p:sp>
-      <p:sp>
-        <p:nvSpPr>
-          <p:cNvPr id="18" name="Oval 17"/>
-          <p:cNvSpPr/>
-          <p:nvPr/>
-        </p:nvSpPr>
-        <p:spPr>
-          <a:xfrm>
-            <a:off x="685800" y="4946904"/>
-            <a:ext cx="164592" cy="164592"/>
-          </a:xfrm>
-          <a:prstGeom prst="ellipse">
-            <a:avLst/>
-          </a:prstGeom>
-          <a:solidFill>
-            <a:srgbClr val="9C4221"/>
-          </a:solidFill>
-          <a:ln>
-            <a:noFill/>
+              <a:t>Nov 2</a:t>
+            </a:r>
+          </a:p>
+        </p:txBody>
+      </p:sp>
+      <p:cxnSp>
+        <p:nvCxnSpPr>
+          <p:cNvPr id="23" name="Connector 22"/>
+          <p:cNvCxnSpPr/>
+          <p:nvPr/>
+        </p:nvCxnSpPr>
+        <p:spPr>
+          <a:xfrm>
+            <a:off x="8605579" y="1737360"/>
+            <a:ext cx="0" cy="2788920"/>
+          </a:xfrm>
+          <a:prstGeom prst="line">
+            <a:avLst/>
+          </a:prstGeom>
+          <a:ln w="9525">
+            <a:solidFill>
+              <a:srgbClr val="DED8CA"/>
+            </a:solidFill>
           </a:ln>
-          <a:effectLst/>
         </p:spPr>
         <p:style>
-          <a:lnRef idx="1">
+          <a:lnRef idx="2">
             <a:schemeClr val="accent1"/>
           </a:lnRef>
-          <a:fillRef idx="3">
+          <a:fillRef idx="0">
             <a:schemeClr val="accent1"/>
           </a:fillRef>
-          <a:effectRef idx="2">
+          <a:effectRef idx="1">
             <a:schemeClr val="accent1"/>
           </a:effectRef>
           <a:fontRef idx="minor">
-            <a:schemeClr val="lt1"/>
+            <a:schemeClr val="tx1"/>
           </a:fontRef>
         </p:style>
-        <p:txBody>
-          <a:bodyPr rtlCol="0" anchor="ctr"/>
-          <a:lstStyle/>
-          <a:p>
-            <a:pPr algn="ctr"/>
-          </a:p>
-        </p:txBody>
-      </p:sp>
-      <p:sp>
-        <p:nvSpPr>
-          <p:cNvPr id="19" name="TextBox 18"/>
+      </p:cxnSp>
+      <p:sp>
+        <p:nvSpPr>
+          <p:cNvPr id="24" name="TextBox 23"/>
           <p:cNvSpPr txBox="1"/>
           <p:nvPr/>
         </p:nvSpPr>
         <p:spPr>
           <a:xfrm>
-            <a:off x="1051560" y="4901184"/>
-            <a:ext cx="914400" cy="274320"/>
+            <a:off x="8642155" y="1508760"/>
+            <a:ext cx="731520" cy="201168"/>
           </a:xfrm>
           <a:prstGeom prst="rect">
             <a:avLst/>
@@ -7519,27 +7676,62 @@
           <a:p>
             <a:pPr algn="l"/>
             <a:r>
-              <a:rPr sz="1500" b="1" i="0">
-                <a:solidFill>
-                  <a:srgbClr val="9C4221"/>
+              <a:rPr sz="900" b="0" i="0">
+                <a:solidFill>
+                  <a:srgbClr val="77716A"/>
                 </a:solidFill>
                 <a:latin typeface="Georgia"/>
               </a:rPr>
-              <a:t>Dec 3</a:t>
-            </a:r>
-          </a:p>
-        </p:txBody>
-      </p:sp>
-      <p:sp>
-        <p:nvSpPr>
-          <p:cNvPr id="20" name="TextBox 19"/>
+              <a:t>Nov 9</a:t>
+            </a:r>
+          </a:p>
+        </p:txBody>
+      </p:sp>
+      <p:cxnSp>
+        <p:nvCxnSpPr>
+          <p:cNvPr id="25" name="Connector 24"/>
+          <p:cNvCxnSpPr/>
+          <p:nvPr/>
+        </p:nvCxnSpPr>
+        <p:spPr>
+          <a:xfrm>
+            <a:off x="9422623" y="1737360"/>
+            <a:ext cx="0" cy="2788920"/>
+          </a:xfrm>
+          <a:prstGeom prst="line">
+            <a:avLst/>
+          </a:prstGeom>
+          <a:ln w="9525">
+            <a:solidFill>
+              <a:srgbClr val="DED8CA"/>
+            </a:solidFill>
+          </a:ln>
+        </p:spPr>
+        <p:style>
+          <a:lnRef idx="2">
+            <a:schemeClr val="accent1"/>
+          </a:lnRef>
+          <a:fillRef idx="0">
+            <a:schemeClr val="accent1"/>
+          </a:fillRef>
+          <a:effectRef idx="1">
+            <a:schemeClr val="accent1"/>
+          </a:effectRef>
+          <a:fontRef idx="minor">
+            <a:schemeClr val="tx1"/>
+          </a:fontRef>
+        </p:style>
+      </p:cxnSp>
+      <p:sp>
+        <p:nvSpPr>
+          <p:cNvPr id="26" name="TextBox 25"/>
           <p:cNvSpPr txBox="1"/>
           <p:nvPr/>
         </p:nvSpPr>
         <p:spPr>
           <a:xfrm>
-            <a:off x="1920240" y="4910328"/>
-            <a:ext cx="4206240" cy="822960"/>
+            <a:off x="9459199" y="1508760"/>
+            <a:ext cx="731520" cy="201168"/>
           </a:xfrm>
           <a:prstGeom prst="rect">
             <a:avLst/>
@@ -7554,27 +7746,62 @@
           <a:p>
             <a:pPr algn="l"/>
             <a:r>
-              <a:rPr sz="1300" b="0" i="0">
-                <a:solidFill>
-                  <a:srgbClr val="15140F"/>
+              <a:rPr sz="900" b="0" i="0">
+                <a:solidFill>
+                  <a:srgbClr val="77716A"/>
                 </a:solidFill>
                 <a:latin typeface="Georgia"/>
               </a:rPr>
-              <a:t>Documentation and a silicon test plan</a:t>
-            </a:r>
-          </a:p>
-        </p:txBody>
-      </p:sp>
-      <p:sp>
-        <p:nvSpPr>
-          <p:cNvPr id="21" name="TextBox 20"/>
+              <a:t>Nov 16</a:t>
+            </a:r>
+          </a:p>
+        </p:txBody>
+      </p:sp>
+      <p:cxnSp>
+        <p:nvCxnSpPr>
+          <p:cNvPr id="27" name="Connector 26"/>
+          <p:cNvCxnSpPr/>
+          <p:nvPr/>
+        </p:nvCxnSpPr>
+        <p:spPr>
+          <a:xfrm>
+            <a:off x="10239666" y="1737360"/>
+            <a:ext cx="0" cy="2788920"/>
+          </a:xfrm>
+          <a:prstGeom prst="line">
+            <a:avLst/>
+          </a:prstGeom>
+          <a:ln w="9525">
+            <a:solidFill>
+              <a:srgbClr val="DED8CA"/>
+            </a:solidFill>
+          </a:ln>
+        </p:spPr>
+        <p:style>
+          <a:lnRef idx="2">
+            <a:schemeClr val="accent1"/>
+          </a:lnRef>
+          <a:fillRef idx="0">
+            <a:schemeClr val="accent1"/>
+          </a:fillRef>
+          <a:effectRef idx="1">
+            <a:schemeClr val="accent1"/>
+          </a:effectRef>
+          <a:fontRef idx="minor">
+            <a:schemeClr val="tx1"/>
+          </a:fontRef>
+        </p:style>
+      </p:cxnSp>
+      <p:sp>
+        <p:nvSpPr>
+          <p:cNvPr id="28" name="TextBox 27"/>
           <p:cNvSpPr txBox="1"/>
           <p:nvPr/>
         </p:nvSpPr>
         <p:spPr>
           <a:xfrm>
-            <a:off x="6400800" y="1508760"/>
-            <a:ext cx="5239512" cy="292608"/>
+            <a:off x="10276242" y="1508760"/>
+            <a:ext cx="731520" cy="201168"/>
           </a:xfrm>
           <a:prstGeom prst="rect">
             <a:avLst/>
@@ -7589,31 +7816,206 @@
           <a:p>
             <a:pPr algn="l"/>
             <a:r>
-              <a:rPr sz="1600" b="1" i="0">
-                <a:solidFill>
-                  <a:srgbClr val="15140F"/>
+              <a:rPr sz="900" b="0" i="0">
+                <a:solidFill>
+                  <a:srgbClr val="77716A"/>
                 </a:solidFill>
                 <a:latin typeface="Georgia"/>
               </a:rPr>
-              <a:t>Who does what</a:t>
-            </a:r>
-          </a:p>
-        </p:txBody>
-      </p:sp>
-      <p:sp>
-        <p:nvSpPr>
-          <p:cNvPr id="22" name="Rounded Rectangle 21"/>
+              <a:t>Nov 23</a:t>
+            </a:r>
+          </a:p>
+        </p:txBody>
+      </p:sp>
+      <p:cxnSp>
+        <p:nvCxnSpPr>
+          <p:cNvPr id="29" name="Connector 28"/>
+          <p:cNvCxnSpPr/>
+          <p:nvPr/>
+        </p:nvCxnSpPr>
+        <p:spPr>
+          <a:xfrm>
+            <a:off x="11056709" y="1737360"/>
+            <a:ext cx="0" cy="2788920"/>
+          </a:xfrm>
+          <a:prstGeom prst="line">
+            <a:avLst/>
+          </a:prstGeom>
+          <a:ln w="9525">
+            <a:solidFill>
+              <a:srgbClr val="DED8CA"/>
+            </a:solidFill>
+          </a:ln>
+        </p:spPr>
+        <p:style>
+          <a:lnRef idx="2">
+            <a:schemeClr val="accent1"/>
+          </a:lnRef>
+          <a:fillRef idx="0">
+            <a:schemeClr val="accent1"/>
+          </a:fillRef>
+          <a:effectRef idx="1">
+            <a:schemeClr val="accent1"/>
+          </a:effectRef>
+          <a:fontRef idx="minor">
+            <a:schemeClr val="tx1"/>
+          </a:fontRef>
+        </p:style>
+      </p:cxnSp>
+      <p:sp>
+        <p:nvSpPr>
+          <p:cNvPr id="30" name="TextBox 29"/>
+          <p:cNvSpPr txBox="1"/>
+          <p:nvPr/>
+        </p:nvSpPr>
+        <p:spPr>
+          <a:xfrm>
+            <a:off x="11093285" y="1508760"/>
+            <a:ext cx="731520" cy="201168"/>
+          </a:xfrm>
+          <a:prstGeom prst="rect">
+            <a:avLst/>
+          </a:prstGeom>
+          <a:noFill/>
+        </p:spPr>
+        <p:txBody>
+          <a:bodyPr wrap="square" lIns="0" rIns="0" tIns="0" bIns="0" anchor="t">
+            <a:spAutoFit/>
+          </a:bodyPr>
+          <a:lstStyle/>
+          <a:p>
+            <a:pPr algn="l"/>
+            <a:r>
+              <a:rPr sz="900" b="0" i="0">
+                <a:solidFill>
+                  <a:srgbClr val="77716A"/>
+                </a:solidFill>
+                <a:latin typeface="Georgia"/>
+              </a:rPr>
+              <a:t>Nov 30</a:t>
+            </a:r>
+          </a:p>
+        </p:txBody>
+      </p:sp>
+      <p:cxnSp>
+        <p:nvCxnSpPr>
+          <p:cNvPr id="31" name="Connector 30"/>
+          <p:cNvCxnSpPr/>
+          <p:nvPr/>
+        </p:nvCxnSpPr>
+        <p:spPr>
+          <a:xfrm>
+            <a:off x="548640" y="1783080"/>
+            <a:ext cx="11091672" cy="0"/>
+          </a:xfrm>
+          <a:prstGeom prst="line">
+            <a:avLst/>
+          </a:prstGeom>
+          <a:ln w="9525">
+            <a:solidFill>
+              <a:srgbClr val="DED8CA"/>
+            </a:solidFill>
+          </a:ln>
+        </p:spPr>
+        <p:style>
+          <a:lnRef idx="2">
+            <a:schemeClr val="accent1"/>
+          </a:lnRef>
+          <a:fillRef idx="0">
+            <a:schemeClr val="accent1"/>
+          </a:fillRef>
+          <a:effectRef idx="1">
+            <a:schemeClr val="accent1"/>
+          </a:effectRef>
+          <a:fontRef idx="minor">
+            <a:schemeClr val="tx1"/>
+          </a:fontRef>
+        </p:style>
+      </p:cxnSp>
+      <p:cxnSp>
+        <p:nvCxnSpPr>
+          <p:cNvPr id="32" name="Connector 31"/>
+          <p:cNvCxnSpPr/>
+          <p:nvPr/>
+        </p:nvCxnSpPr>
+        <p:spPr>
+          <a:xfrm>
+            <a:off x="548640" y="4526280"/>
+            <a:ext cx="11091672" cy="0"/>
+          </a:xfrm>
+          <a:prstGeom prst="line">
+            <a:avLst/>
+          </a:prstGeom>
+          <a:ln w="9525">
+            <a:solidFill>
+              <a:srgbClr val="DED8CA"/>
+            </a:solidFill>
+          </a:ln>
+        </p:spPr>
+        <p:style>
+          <a:lnRef idx="2">
+            <a:schemeClr val="accent1"/>
+          </a:lnRef>
+          <a:fillRef idx="0">
+            <a:schemeClr val="accent1"/>
+          </a:fillRef>
+          <a:effectRef idx="1">
+            <a:schemeClr val="accent1"/>
+          </a:effectRef>
+          <a:fontRef idx="minor">
+            <a:schemeClr val="tx1"/>
+          </a:fontRef>
+        </p:style>
+      </p:cxnSp>
+      <p:sp>
+        <p:nvSpPr>
+          <p:cNvPr id="33" name="TextBox 32"/>
+          <p:cNvSpPr txBox="1"/>
+          <p:nvPr/>
+        </p:nvSpPr>
+        <p:spPr>
+          <a:xfrm>
+            <a:off x="548640" y="1783080"/>
+            <a:ext cx="3063240" cy="274320"/>
+          </a:xfrm>
+          <a:prstGeom prst="rect">
+            <a:avLst/>
+          </a:prstGeom>
+          <a:noFill/>
+        </p:spPr>
+        <p:txBody>
+          <a:bodyPr wrap="square" lIns="0" rIns="0" tIns="0" bIns="0" anchor="ctr">
+            <a:spAutoFit/>
+          </a:bodyPr>
+          <a:lstStyle/>
+          <a:p>
+            <a:pPr algn="l"/>
+            <a:r>
+              <a:rPr sz="1100" b="0" i="0">
+                <a:solidFill>
+                  <a:srgbClr val="15140F"/>
+                </a:solidFill>
+                <a:latin typeface="Georgia"/>
+              </a:rPr>
+              <a:t>PFD RTL and CocoTB</a:t>
+            </a:r>
+          </a:p>
+        </p:txBody>
+      </p:sp>
+      <p:sp>
+        <p:nvSpPr>
+          <p:cNvPr id="34" name="Rounded Rectangle 33"/>
           <p:cNvSpPr/>
           <p:nvPr/>
         </p:nvSpPr>
         <p:spPr>
           <a:xfrm>
-            <a:off x="6400800" y="1920240"/>
-            <a:ext cx="5239512" cy="1207007"/>
+            <a:off x="4053481" y="1847088"/>
+            <a:ext cx="1750807" cy="146303"/>
           </a:xfrm>
           <a:prstGeom prst="roundRect">
             <a:avLst>
-              <a:gd name="adj" fmla="val 6000"/>
+              <a:gd name="adj" fmla="val 30000"/>
             </a:avLst>
           </a:prstGeom>
           <a:solidFill>
@@ -7650,14 +8052,14 @@
       </p:sp>
       <p:sp>
         <p:nvSpPr>
-          <p:cNvPr id="23" name="TextBox 22"/>
+          <p:cNvPr id="35" name="TextBox 34"/>
           <p:cNvSpPr txBox="1"/>
           <p:nvPr/>
         </p:nvSpPr>
         <p:spPr>
           <a:xfrm>
-            <a:off x="6583680" y="2011680"/>
-            <a:ext cx="2926080" cy="274320"/>
+            <a:off x="548640" y="2057400"/>
+            <a:ext cx="3063240" cy="274320"/>
           </a:xfrm>
           <a:prstGeom prst="rect">
             <a:avLst/>
@@ -7665,150 +8067,38 @@
           <a:noFill/>
         </p:spPr>
         <p:txBody>
-          <a:bodyPr wrap="square" lIns="0" rIns="0" tIns="0" bIns="0" anchor="t">
+          <a:bodyPr wrap="square" lIns="0" rIns="0" tIns="0" bIns="0" anchor="ctr">
             <a:spAutoFit/>
           </a:bodyPr>
           <a:lstStyle/>
           <a:p>
             <a:pPr algn="l"/>
             <a:r>
-              <a:rPr sz="1500" b="1" i="0">
+              <a:rPr sz="1100" b="0" i="0">
                 <a:solidFill>
                   <a:srgbClr val="15140F"/>
                 </a:solidFill>
                 <a:latin typeface="Georgia"/>
               </a:rPr>
-              <a:t>Ihsan Salari</a:t>
-            </a:r>
-          </a:p>
-        </p:txBody>
-      </p:sp>
-      <p:sp>
-        <p:nvSpPr>
-          <p:cNvPr id="24" name="TextBox 23"/>
-          <p:cNvSpPr txBox="1"/>
-          <p:nvPr/>
-        </p:nvSpPr>
-        <p:spPr>
-          <a:xfrm>
-            <a:off x="9601200" y="2029968"/>
-            <a:ext cx="1874519" cy="274320"/>
-          </a:xfrm>
-          <a:prstGeom prst="rect">
-            <a:avLst/>
-          </a:prstGeom>
-          <a:noFill/>
-        </p:spPr>
-        <p:txBody>
-          <a:bodyPr wrap="square" lIns="0" rIns="0" tIns="0" bIns="0" anchor="t">
-            <a:spAutoFit/>
-          </a:bodyPr>
-          <a:lstStyle/>
-          <a:p>
-            <a:pPr algn="r"/>
-            <a:r>
-              <a:rPr sz="1100" b="1" i="0">
-                <a:solidFill>
-                  <a:srgbClr val="5E7A5A"/>
-                </a:solidFill>
-                <a:latin typeface="Georgia"/>
-              </a:rPr>
-              <a:t>DETECT AND FILTER</a:t>
-            </a:r>
-          </a:p>
-        </p:txBody>
-      </p:sp>
-      <p:sp>
-        <p:nvSpPr>
-          <p:cNvPr id="25" name="TextBox 24"/>
-          <p:cNvSpPr txBox="1"/>
-          <p:nvPr/>
-        </p:nvSpPr>
-        <p:spPr>
-          <a:xfrm>
-            <a:off x="6583680" y="2304288"/>
-            <a:ext cx="4892040" cy="822959"/>
-          </a:xfrm>
-          <a:prstGeom prst="rect">
-            <a:avLst/>
-          </a:prstGeom>
-          <a:noFill/>
-        </p:spPr>
-        <p:txBody>
-          <a:bodyPr wrap="square" lIns="0" rIns="0" tIns="0" bIns="0" anchor="t">
-            <a:spAutoFit/>
-          </a:bodyPr>
-          <a:lstStyle/>
-          <a:p>
-            <a:pPr algn="l" marL="228600" indent="-228600">
-              <a:buClr>
-                <a:srgbClr val="5E7A5A"/>
-              </a:buClr>
-              <a:buFont typeface="Arial"/>
-              <a:buChar char="•"/>
-            </a:pPr>
-            <a:r>
-              <a:rPr sz="1200" b="0" i="0">
-                <a:solidFill>
-                  <a:srgbClr val="15140F"/>
-                </a:solidFill>
-                <a:latin typeface="Georgia"/>
-              </a:rPr>
-              <a:t>PFD and charge pump</a:t>
-            </a:r>
-          </a:p>
-          <a:p>
-            <a:pPr algn="l" marL="228600" indent="-228600">
-              <a:buClr>
-                <a:srgbClr val="5E7A5A"/>
-              </a:buClr>
-              <a:buFont typeface="Arial"/>
-              <a:buChar char="•"/>
-            </a:pPr>
-            <a:r>
-              <a:rPr sz="1200" b="0" i="0">
-                <a:solidFill>
-                  <a:srgbClr val="15140F"/>
-                </a:solidFill>
-                <a:latin typeface="Georgia"/>
-              </a:rPr>
-              <a:t>Loop filter</a:t>
-            </a:r>
-          </a:p>
-          <a:p>
-            <a:pPr algn="l" marL="228600" indent="-228600">
-              <a:buClr>
-                <a:srgbClr val="5E7A5A"/>
-              </a:buClr>
-              <a:buFont typeface="Arial"/>
-              <a:buChar char="•"/>
-            </a:pPr>
-            <a:r>
-              <a:rPr sz="1200" b="0" i="0">
-                <a:solidFill>
-                  <a:srgbClr val="15140F"/>
-                </a:solidFill>
-                <a:latin typeface="Georgia"/>
-              </a:rPr>
-              <a:t>Design, simulation and layout of these stages</a:t>
-            </a:r>
-          </a:p>
-        </p:txBody>
-      </p:sp>
-      <p:sp>
-        <p:nvSpPr>
-          <p:cNvPr id="26" name="Rounded Rectangle 25"/>
+              <a:t>Prescaler, divider, lock detector RTL</a:t>
+            </a:r>
+          </a:p>
+        </p:txBody>
+      </p:sp>
+      <p:sp>
+        <p:nvSpPr>
+          <p:cNvPr id="36" name="Rounded Rectangle 35"/>
           <p:cNvSpPr/>
           <p:nvPr/>
         </p:nvSpPr>
         <p:spPr>
           <a:xfrm>
-            <a:off x="6400800" y="3310128"/>
-            <a:ext cx="5239512" cy="1207007"/>
+            <a:off x="4053481" y="2121408"/>
+            <a:ext cx="1750807" cy="146303"/>
           </a:xfrm>
           <a:prstGeom prst="roundRect">
             <a:avLst>
-              <a:gd name="adj" fmla="val 6000"/>
+              <a:gd name="adj" fmla="val 30000"/>
             </a:avLst>
           </a:prstGeom>
           <a:solidFill>
@@ -7845,14 +8135,14 @@
       </p:sp>
       <p:sp>
         <p:nvSpPr>
-          <p:cNvPr id="27" name="TextBox 26"/>
+          <p:cNvPr id="37" name="TextBox 36"/>
           <p:cNvSpPr txBox="1"/>
           <p:nvPr/>
         </p:nvSpPr>
         <p:spPr>
           <a:xfrm>
-            <a:off x="6583680" y="3401568"/>
-            <a:ext cx="2926080" cy="274320"/>
+            <a:off x="548640" y="2331720"/>
+            <a:ext cx="3063240" cy="274320"/>
           </a:xfrm>
           <a:prstGeom prst="rect">
             <a:avLst/>
@@ -7860,150 +8150,38 @@
           <a:noFill/>
         </p:spPr>
         <p:txBody>
-          <a:bodyPr wrap="square" lIns="0" rIns="0" tIns="0" bIns="0" anchor="t">
+          <a:bodyPr wrap="square" lIns="0" rIns="0" tIns="0" bIns="0" anchor="ctr">
             <a:spAutoFit/>
           </a:bodyPr>
           <a:lstStyle/>
           <a:p>
             <a:pPr algn="l"/>
             <a:r>
-              <a:rPr sz="1500" b="1" i="0">
+              <a:rPr sz="1100" b="0" i="0">
                 <a:solidFill>
                   <a:srgbClr val="15140F"/>
                 </a:solidFill>
                 <a:latin typeface="Georgia"/>
               </a:rPr>
-              <a:t>Dhyey Bhatt</a:t>
-            </a:r>
-          </a:p>
-        </p:txBody>
-      </p:sp>
-      <p:sp>
-        <p:nvSpPr>
-          <p:cNvPr id="28" name="TextBox 27"/>
-          <p:cNvSpPr txBox="1"/>
-          <p:nvPr/>
-        </p:nvSpPr>
-        <p:spPr>
-          <a:xfrm>
-            <a:off x="9601200" y="3419856"/>
-            <a:ext cx="1874519" cy="274320"/>
-          </a:xfrm>
-          <a:prstGeom prst="rect">
-            <a:avLst/>
-          </a:prstGeom>
-          <a:noFill/>
-        </p:spPr>
-        <p:txBody>
-          <a:bodyPr wrap="square" lIns="0" rIns="0" tIns="0" bIns="0" anchor="t">
-            <a:spAutoFit/>
-          </a:bodyPr>
-          <a:lstStyle/>
-          <a:p>
-            <a:pPr algn="r"/>
-            <a:r>
-              <a:rPr sz="1100" b="1" i="0">
-                <a:solidFill>
-                  <a:srgbClr val="77716A"/>
-                </a:solidFill>
-                <a:latin typeface="Georgia"/>
-              </a:rPr>
-              <a:t>OSCILLATE AND DIVIDE</a:t>
-            </a:r>
-          </a:p>
-        </p:txBody>
-      </p:sp>
-      <p:sp>
-        <p:nvSpPr>
-          <p:cNvPr id="29" name="TextBox 28"/>
-          <p:cNvSpPr txBox="1"/>
-          <p:nvPr/>
-        </p:nvSpPr>
-        <p:spPr>
-          <a:xfrm>
-            <a:off x="6583680" y="3694176"/>
-            <a:ext cx="4892040" cy="822959"/>
-          </a:xfrm>
-          <a:prstGeom prst="rect">
-            <a:avLst/>
-          </a:prstGeom>
-          <a:noFill/>
-        </p:spPr>
-        <p:txBody>
-          <a:bodyPr wrap="square" lIns="0" rIns="0" tIns="0" bIns="0" anchor="t">
-            <a:spAutoFit/>
-          </a:bodyPr>
-          <a:lstStyle/>
-          <a:p>
-            <a:pPr algn="l" marL="228600" indent="-228600">
-              <a:buClr>
-                <a:srgbClr val="77716A"/>
-              </a:buClr>
-              <a:buFont typeface="Arial"/>
-              <a:buChar char="•"/>
-            </a:pPr>
-            <a:r>
-              <a:rPr sz="1200" b="0" i="0">
-                <a:solidFill>
-                  <a:srgbClr val="15140F"/>
-                </a:solidFill>
-                <a:latin typeface="Georgia"/>
-              </a:rPr>
-              <a:t>VCO</a:t>
-            </a:r>
-          </a:p>
-          <a:p>
-            <a:pPr algn="l" marL="228600" indent="-228600">
-              <a:buClr>
-                <a:srgbClr val="77716A"/>
-              </a:buClr>
-              <a:buFont typeface="Arial"/>
-              <a:buChar char="•"/>
-            </a:pPr>
-            <a:r>
-              <a:rPr sz="1200" b="0" i="0">
-                <a:solidFill>
-                  <a:srgbClr val="15140F"/>
-                </a:solidFill>
-                <a:latin typeface="Georgia"/>
-              </a:rPr>
-              <a:t>Prescaler, ÷N divider and lock detector</a:t>
-            </a:r>
-          </a:p>
-          <a:p>
-            <a:pPr algn="l" marL="228600" indent="-228600">
-              <a:buClr>
-                <a:srgbClr val="77716A"/>
-              </a:buClr>
-              <a:buFont typeface="Arial"/>
-              <a:buChar char="•"/>
-            </a:pPr>
-            <a:r>
-              <a:rPr sz="1200" b="0" i="0">
-                <a:solidFill>
-                  <a:srgbClr val="15140F"/>
-                </a:solidFill>
-                <a:latin typeface="Georgia"/>
-              </a:rPr>
-              <a:t>Design, simulation and layout of these stages</a:t>
-            </a:r>
-          </a:p>
-        </p:txBody>
-      </p:sp>
-      <p:sp>
-        <p:nvSpPr>
-          <p:cNvPr id="30" name="Rounded Rectangle 29"/>
+              <a:t>Loop model and loop CocoTB</a:t>
+            </a:r>
+          </a:p>
+        </p:txBody>
+      </p:sp>
+      <p:sp>
+        <p:nvSpPr>
+          <p:cNvPr id="38" name="Rounded Rectangle 37"/>
           <p:cNvSpPr/>
           <p:nvPr/>
         </p:nvSpPr>
         <p:spPr>
           <a:xfrm>
-            <a:off x="6400800" y="4700016"/>
-            <a:ext cx="5239512" cy="932688"/>
+            <a:off x="4520363" y="2395727"/>
+            <a:ext cx="1283925" cy="146303"/>
           </a:xfrm>
           <a:prstGeom prst="roundRect">
             <a:avLst>
-              <a:gd name="adj" fmla="val 6000"/>
+              <a:gd name="adj" fmla="val 30000"/>
             </a:avLst>
           </a:prstGeom>
           <a:solidFill>
@@ -8040,14 +8218,911 @@
       </p:sp>
       <p:sp>
         <p:nvSpPr>
-          <p:cNvPr id="31" name="TextBox 30"/>
+          <p:cNvPr id="39" name="TextBox 38"/>
           <p:cNvSpPr txBox="1"/>
           <p:nvPr/>
         </p:nvSpPr>
         <p:spPr>
           <a:xfrm>
-            <a:off x="6583680" y="4791455"/>
-            <a:ext cx="2926080" cy="274320"/>
+            <a:off x="548640" y="2606039"/>
+            <a:ext cx="3063240" cy="274320"/>
+          </a:xfrm>
+          <a:prstGeom prst="rect">
+            <a:avLst/>
+          </a:prstGeom>
+          <a:noFill/>
+        </p:spPr>
+        <p:txBody>
+          <a:bodyPr wrap="square" lIns="0" rIns="0" tIns="0" bIns="0" anchor="ctr">
+            <a:spAutoFit/>
+          </a:bodyPr>
+          <a:lstStyle/>
+          <a:p>
+            <a:pPr algn="l"/>
+            <a:r>
+              <a:rPr sz="1100" b="0" i="0">
+                <a:solidFill>
+                  <a:srgbClr val="15140F"/>
+                </a:solidFill>
+                <a:latin typeface="Georgia"/>
+              </a:rPr>
+              <a:t>Charge pump and loop filter in ngspice</a:t>
+            </a:r>
+          </a:p>
+        </p:txBody>
+      </p:sp>
+      <p:sp>
+        <p:nvSpPr>
+          <p:cNvPr id="40" name="Rounded Rectangle 39"/>
+          <p:cNvSpPr/>
+          <p:nvPr/>
+        </p:nvSpPr>
+        <p:spPr>
+          <a:xfrm>
+            <a:off x="4520363" y="2670047"/>
+            <a:ext cx="3618334" cy="146303"/>
+          </a:xfrm>
+          <a:prstGeom prst="roundRect">
+            <a:avLst>
+              <a:gd name="adj" fmla="val 30000"/>
+            </a:avLst>
+          </a:prstGeom>
+          <a:solidFill>
+            <a:srgbClr val="ECEFEB"/>
+          </a:solidFill>
+          <a:ln w="12700">
+            <a:solidFill>
+              <a:srgbClr val="5E7A5A"/>
+            </a:solidFill>
+          </a:ln>
+          <a:effectLst/>
+        </p:spPr>
+        <p:style>
+          <a:lnRef idx="1">
+            <a:schemeClr val="accent1"/>
+          </a:lnRef>
+          <a:fillRef idx="3">
+            <a:schemeClr val="accent1"/>
+          </a:fillRef>
+          <a:effectRef idx="2">
+            <a:schemeClr val="accent1"/>
+          </a:effectRef>
+          <a:fontRef idx="minor">
+            <a:schemeClr val="lt1"/>
+          </a:fontRef>
+        </p:style>
+        <p:txBody>
+          <a:bodyPr rtlCol="0" anchor="ctr"/>
+          <a:lstStyle/>
+          <a:p>
+            <a:pPr algn="ctr"/>
+          </a:p>
+        </p:txBody>
+      </p:sp>
+      <p:sp>
+        <p:nvSpPr>
+          <p:cNvPr id="41" name="TextBox 40"/>
+          <p:cNvSpPr txBox="1"/>
+          <p:nvPr/>
+        </p:nvSpPr>
+        <p:spPr>
+          <a:xfrm>
+            <a:off x="548640" y="2880360"/>
+            <a:ext cx="3063240" cy="274320"/>
+          </a:xfrm>
+          <a:prstGeom prst="rect">
+            <a:avLst/>
+          </a:prstGeom>
+          <a:noFill/>
+        </p:spPr>
+        <p:txBody>
+          <a:bodyPr wrap="square" lIns="0" rIns="0" tIns="0" bIns="0" anchor="ctr">
+            <a:spAutoFit/>
+          </a:bodyPr>
+          <a:lstStyle/>
+          <a:p>
+            <a:pPr algn="l"/>
+            <a:r>
+              <a:rPr sz="1100" b="0" i="0">
+                <a:solidFill>
+                  <a:srgbClr val="15140F"/>
+                </a:solidFill>
+                <a:latin typeface="Georgia"/>
+              </a:rPr>
+              <a:t>VCO in ngspice, all corners</a:t>
+            </a:r>
+          </a:p>
+        </p:txBody>
+      </p:sp>
+      <p:sp>
+        <p:nvSpPr>
+          <p:cNvPr id="42" name="Rounded Rectangle 41"/>
+          <p:cNvSpPr/>
+          <p:nvPr/>
+        </p:nvSpPr>
+        <p:spPr>
+          <a:xfrm>
+            <a:off x="4520363" y="2944368"/>
+            <a:ext cx="3618334" cy="146303"/>
+          </a:xfrm>
+          <a:prstGeom prst="roundRect">
+            <a:avLst>
+              <a:gd name="adj" fmla="val 30000"/>
+            </a:avLst>
+          </a:prstGeom>
+          <a:solidFill>
+            <a:srgbClr val="F0EADE"/>
+          </a:solidFill>
+          <a:ln w="12700">
+            <a:solidFill>
+              <a:srgbClr val="77716A"/>
+            </a:solidFill>
+          </a:ln>
+          <a:effectLst/>
+        </p:spPr>
+        <p:style>
+          <a:lnRef idx="1">
+            <a:schemeClr val="accent1"/>
+          </a:lnRef>
+          <a:fillRef idx="3">
+            <a:schemeClr val="accent1"/>
+          </a:fillRef>
+          <a:effectRef idx="2">
+            <a:schemeClr val="accent1"/>
+          </a:effectRef>
+          <a:fontRef idx="minor">
+            <a:schemeClr val="lt1"/>
+          </a:fontRef>
+        </p:style>
+        <p:txBody>
+          <a:bodyPr rtlCol="0" anchor="ctr"/>
+          <a:lstStyle/>
+          <a:p>
+            <a:pPr algn="ctr"/>
+          </a:p>
+        </p:txBody>
+      </p:sp>
+      <p:sp>
+        <p:nvSpPr>
+          <p:cNvPr id="43" name="TextBox 42"/>
+          <p:cNvSpPr txBox="1"/>
+          <p:nvPr/>
+        </p:nvSpPr>
+        <p:spPr>
+          <a:xfrm>
+            <a:off x="548640" y="3154680"/>
+            <a:ext cx="3063240" cy="274320"/>
+          </a:xfrm>
+          <a:prstGeom prst="rect">
+            <a:avLst/>
+          </a:prstGeom>
+          <a:noFill/>
+        </p:spPr>
+        <p:txBody>
+          <a:bodyPr wrap="square" lIns="0" rIns="0" tIns="0" bIns="0" anchor="ctr">
+            <a:spAutoFit/>
+          </a:bodyPr>
+          <a:lstStyle/>
+          <a:p>
+            <a:pPr algn="l"/>
+            <a:r>
+              <a:rPr sz="1100" b="0" i="0">
+                <a:solidFill>
+                  <a:srgbClr val="15140F"/>
+                </a:solidFill>
+                <a:latin typeface="Georgia"/>
+              </a:rPr>
+              <a:t>Full loop locks in simulation</a:t>
+            </a:r>
+          </a:p>
+        </p:txBody>
+      </p:sp>
+      <p:sp>
+        <p:nvSpPr>
+          <p:cNvPr id="44" name="Rounded Rectangle 43"/>
+          <p:cNvSpPr/>
+          <p:nvPr/>
+        </p:nvSpPr>
+        <p:spPr>
+          <a:xfrm>
+            <a:off x="6971493" y="3218688"/>
+            <a:ext cx="1167204" cy="146303"/>
+          </a:xfrm>
+          <a:prstGeom prst="roundRect">
+            <a:avLst>
+              <a:gd name="adj" fmla="val 30000"/>
+            </a:avLst>
+          </a:prstGeom>
+          <a:solidFill>
+            <a:srgbClr val="EAEDF1"/>
+          </a:solidFill>
+          <a:ln w="12700">
+            <a:solidFill>
+              <a:srgbClr val="4F6D8A"/>
+            </a:solidFill>
+          </a:ln>
+          <a:effectLst/>
+        </p:spPr>
+        <p:style>
+          <a:lnRef idx="1">
+            <a:schemeClr val="accent1"/>
+          </a:lnRef>
+          <a:fillRef idx="3">
+            <a:schemeClr val="accent1"/>
+          </a:fillRef>
+          <a:effectRef idx="2">
+            <a:schemeClr val="accent1"/>
+          </a:effectRef>
+          <a:fontRef idx="minor">
+            <a:schemeClr val="lt1"/>
+          </a:fontRef>
+        </p:style>
+        <p:txBody>
+          <a:bodyPr rtlCol="0" anchor="ctr"/>
+          <a:lstStyle/>
+          <a:p>
+            <a:pPr algn="ctr"/>
+          </a:p>
+        </p:txBody>
+      </p:sp>
+      <p:sp>
+        <p:nvSpPr>
+          <p:cNvPr id="45" name="TextBox 44"/>
+          <p:cNvSpPr txBox="1"/>
+          <p:nvPr/>
+        </p:nvSpPr>
+        <p:spPr>
+          <a:xfrm>
+            <a:off x="548640" y="3429000"/>
+            <a:ext cx="3063240" cy="274320"/>
+          </a:xfrm>
+          <a:prstGeom prst="rect">
+            <a:avLst/>
+          </a:prstGeom>
+          <a:noFill/>
+        </p:spPr>
+        <p:txBody>
+          <a:bodyPr wrap="square" lIns="0" rIns="0" tIns="0" bIns="0" anchor="ctr">
+            <a:spAutoFit/>
+          </a:bodyPr>
+          <a:lstStyle/>
+          <a:p>
+            <a:pPr algn="l"/>
+            <a:r>
+              <a:rPr sz="1100" b="0" i="0">
+                <a:solidFill>
+                  <a:srgbClr val="15140F"/>
+                </a:solidFill>
+                <a:latin typeface="Georgia"/>
+              </a:rPr>
+              <a:t>PFD, pump and filter layout, DRC, LVS</a:t>
+            </a:r>
+          </a:p>
+        </p:txBody>
+      </p:sp>
+      <p:sp>
+        <p:nvSpPr>
+          <p:cNvPr id="46" name="Rounded Rectangle 45"/>
+          <p:cNvSpPr/>
+          <p:nvPr/>
+        </p:nvSpPr>
+        <p:spPr>
+          <a:xfrm>
+            <a:off x="7788536" y="3493008"/>
+            <a:ext cx="2100968" cy="146303"/>
+          </a:xfrm>
+          <a:prstGeom prst="roundRect">
+            <a:avLst>
+              <a:gd name="adj" fmla="val 30000"/>
+            </a:avLst>
+          </a:prstGeom>
+          <a:solidFill>
+            <a:srgbClr val="ECEFEB"/>
+          </a:solidFill>
+          <a:ln w="12700">
+            <a:solidFill>
+              <a:srgbClr val="5E7A5A"/>
+            </a:solidFill>
+          </a:ln>
+          <a:effectLst/>
+        </p:spPr>
+        <p:style>
+          <a:lnRef idx="1">
+            <a:schemeClr val="accent1"/>
+          </a:lnRef>
+          <a:fillRef idx="3">
+            <a:schemeClr val="accent1"/>
+          </a:fillRef>
+          <a:effectRef idx="2">
+            <a:schemeClr val="accent1"/>
+          </a:effectRef>
+          <a:fontRef idx="minor">
+            <a:schemeClr val="lt1"/>
+          </a:fontRef>
+        </p:style>
+        <p:txBody>
+          <a:bodyPr rtlCol="0" anchor="ctr"/>
+          <a:lstStyle/>
+          <a:p>
+            <a:pPr algn="ctr"/>
+          </a:p>
+        </p:txBody>
+      </p:sp>
+      <p:sp>
+        <p:nvSpPr>
+          <p:cNvPr id="47" name="TextBox 46"/>
+          <p:cNvSpPr txBox="1"/>
+          <p:nvPr/>
+        </p:nvSpPr>
+        <p:spPr>
+          <a:xfrm>
+            <a:off x="548640" y="3703320"/>
+            <a:ext cx="3063240" cy="274320"/>
+          </a:xfrm>
+          <a:prstGeom prst="rect">
+            <a:avLst/>
+          </a:prstGeom>
+          <a:noFill/>
+        </p:spPr>
+        <p:txBody>
+          <a:bodyPr wrap="square" lIns="0" rIns="0" tIns="0" bIns="0" anchor="ctr">
+            <a:spAutoFit/>
+          </a:bodyPr>
+          <a:lstStyle/>
+          <a:p>
+            <a:pPr algn="l"/>
+            <a:r>
+              <a:rPr sz="1100" b="0" i="0">
+                <a:solidFill>
+                  <a:srgbClr val="15140F"/>
+                </a:solidFill>
+                <a:latin typeface="Georgia"/>
+              </a:rPr>
+              <a:t>VCO, prescaler, divider layout, DRC, LVS</a:t>
+            </a:r>
+          </a:p>
+        </p:txBody>
+      </p:sp>
+      <p:sp>
+        <p:nvSpPr>
+          <p:cNvPr id="48" name="Rounded Rectangle 47"/>
+          <p:cNvSpPr/>
+          <p:nvPr/>
+        </p:nvSpPr>
+        <p:spPr>
+          <a:xfrm>
+            <a:off x="7788536" y="3767328"/>
+            <a:ext cx="2100968" cy="146303"/>
+          </a:xfrm>
+          <a:prstGeom prst="roundRect">
+            <a:avLst>
+              <a:gd name="adj" fmla="val 30000"/>
+            </a:avLst>
+          </a:prstGeom>
+          <a:solidFill>
+            <a:srgbClr val="F0EADE"/>
+          </a:solidFill>
+          <a:ln w="12700">
+            <a:solidFill>
+              <a:srgbClr val="77716A"/>
+            </a:solidFill>
+          </a:ln>
+          <a:effectLst/>
+        </p:spPr>
+        <p:style>
+          <a:lnRef idx="1">
+            <a:schemeClr val="accent1"/>
+          </a:lnRef>
+          <a:fillRef idx="3">
+            <a:schemeClr val="accent1"/>
+          </a:fillRef>
+          <a:effectRef idx="2">
+            <a:schemeClr val="accent1"/>
+          </a:effectRef>
+          <a:fontRef idx="minor">
+            <a:schemeClr val="lt1"/>
+          </a:fontRef>
+        </p:style>
+        <p:txBody>
+          <a:bodyPr rtlCol="0" anchor="ctr"/>
+          <a:lstStyle/>
+          <a:p>
+            <a:pPr algn="ctr"/>
+          </a:p>
+        </p:txBody>
+      </p:sp>
+      <p:sp>
+        <p:nvSpPr>
+          <p:cNvPr id="49" name="TextBox 48"/>
+          <p:cNvSpPr txBox="1"/>
+          <p:nvPr/>
+        </p:nvSpPr>
+        <p:spPr>
+          <a:xfrm>
+            <a:off x="548640" y="3977639"/>
+            <a:ext cx="3063240" cy="274320"/>
+          </a:xfrm>
+          <a:prstGeom prst="rect">
+            <a:avLst/>
+          </a:prstGeom>
+          <a:noFill/>
+        </p:spPr>
+        <p:txBody>
+          <a:bodyPr wrap="square" lIns="0" rIns="0" tIns="0" bIns="0" anchor="ctr">
+            <a:spAutoFit/>
+          </a:bodyPr>
+          <a:lstStyle/>
+          <a:p>
+            <a:pPr algn="l"/>
+            <a:r>
+              <a:rPr sz="1100" b="0" i="0">
+                <a:solidFill>
+                  <a:srgbClr val="15140F"/>
+                </a:solidFill>
+                <a:latin typeface="Georgia"/>
+              </a:rPr>
+              <a:t>Tile integration, post-layout sim, precheck</a:t>
+            </a:r>
+          </a:p>
+        </p:txBody>
+      </p:sp>
+      <p:sp>
+        <p:nvSpPr>
+          <p:cNvPr id="50" name="Rounded Rectangle 49"/>
+          <p:cNvSpPr/>
+          <p:nvPr/>
+        </p:nvSpPr>
+        <p:spPr>
+          <a:xfrm>
+            <a:off x="9422623" y="4041648"/>
+            <a:ext cx="1167204" cy="146303"/>
+          </a:xfrm>
+          <a:prstGeom prst="roundRect">
+            <a:avLst>
+              <a:gd name="adj" fmla="val 30000"/>
+            </a:avLst>
+          </a:prstGeom>
+          <a:solidFill>
+            <a:srgbClr val="EAEDF1"/>
+          </a:solidFill>
+          <a:ln w="12700">
+            <a:solidFill>
+              <a:srgbClr val="4F6D8A"/>
+            </a:solidFill>
+          </a:ln>
+          <a:effectLst/>
+        </p:spPr>
+        <p:style>
+          <a:lnRef idx="1">
+            <a:schemeClr val="accent1"/>
+          </a:lnRef>
+          <a:fillRef idx="3">
+            <a:schemeClr val="accent1"/>
+          </a:fillRef>
+          <a:effectRef idx="2">
+            <a:schemeClr val="accent1"/>
+          </a:effectRef>
+          <a:fontRef idx="minor">
+            <a:schemeClr val="lt1"/>
+          </a:fontRef>
+        </p:style>
+        <p:txBody>
+          <a:bodyPr rtlCol="0" anchor="ctr"/>
+          <a:lstStyle/>
+          <a:p>
+            <a:pPr algn="ctr"/>
+          </a:p>
+        </p:txBody>
+      </p:sp>
+      <p:sp>
+        <p:nvSpPr>
+          <p:cNvPr id="51" name="TextBox 50"/>
+          <p:cNvSpPr txBox="1"/>
+          <p:nvPr/>
+        </p:nvSpPr>
+        <p:spPr>
+          <a:xfrm>
+            <a:off x="548640" y="4251959"/>
+            <a:ext cx="3063240" cy="274320"/>
+          </a:xfrm>
+          <a:prstGeom prst="rect">
+            <a:avLst/>
+          </a:prstGeom>
+          <a:noFill/>
+        </p:spPr>
+        <p:txBody>
+          <a:bodyPr wrap="square" lIns="0" rIns="0" tIns="0" bIns="0" anchor="ctr">
+            <a:spAutoFit/>
+          </a:bodyPr>
+          <a:lstStyle/>
+          <a:p>
+            <a:pPr algn="l"/>
+            <a:r>
+              <a:rPr sz="1100" b="0" i="0">
+                <a:solidFill>
+                  <a:srgbClr val="15140F"/>
+                </a:solidFill>
+                <a:latin typeface="Georgia"/>
+              </a:rPr>
+              <a:t>Documentation and silicon test plan</a:t>
+            </a:r>
+          </a:p>
+        </p:txBody>
+      </p:sp>
+      <p:sp>
+        <p:nvSpPr>
+          <p:cNvPr id="52" name="Rounded Rectangle 51"/>
+          <p:cNvSpPr/>
+          <p:nvPr/>
+        </p:nvSpPr>
+        <p:spPr>
+          <a:xfrm>
+            <a:off x="10239666" y="4315968"/>
+            <a:ext cx="1167204" cy="146303"/>
+          </a:xfrm>
+          <a:prstGeom prst="roundRect">
+            <a:avLst>
+              <a:gd name="adj" fmla="val 30000"/>
+            </a:avLst>
+          </a:prstGeom>
+          <a:solidFill>
+            <a:srgbClr val="EAEDF1"/>
+          </a:solidFill>
+          <a:ln w="12700">
+            <a:solidFill>
+              <a:srgbClr val="4F6D8A"/>
+            </a:solidFill>
+          </a:ln>
+          <a:effectLst/>
+        </p:spPr>
+        <p:style>
+          <a:lnRef idx="1">
+            <a:schemeClr val="accent1"/>
+          </a:lnRef>
+          <a:fillRef idx="3">
+            <a:schemeClr val="accent1"/>
+          </a:fillRef>
+          <a:effectRef idx="2">
+            <a:schemeClr val="accent1"/>
+          </a:effectRef>
+          <a:fontRef idx="minor">
+            <a:schemeClr val="lt1"/>
+          </a:fontRef>
+        </p:style>
+        <p:txBody>
+          <a:bodyPr rtlCol="0" anchor="ctr"/>
+          <a:lstStyle/>
+          <a:p>
+            <a:pPr algn="ctr"/>
+          </a:p>
+        </p:txBody>
+      </p:sp>
+      <p:cxnSp>
+        <p:nvCxnSpPr>
+          <p:cNvPr id="53" name="Connector 52"/>
+          <p:cNvCxnSpPr/>
+          <p:nvPr/>
+        </p:nvCxnSpPr>
+        <p:spPr>
+          <a:xfrm>
+            <a:off x="5804288" y="1737360"/>
+            <a:ext cx="0" cy="2788920"/>
+          </a:xfrm>
+          <a:prstGeom prst="line">
+            <a:avLst/>
+          </a:prstGeom>
+          <a:ln w="15875">
+            <a:solidFill>
+              <a:srgbClr val="9C4221"/>
+            </a:solidFill>
+          </a:ln>
+        </p:spPr>
+        <p:style>
+          <a:lnRef idx="2">
+            <a:schemeClr val="accent1"/>
+          </a:lnRef>
+          <a:fillRef idx="0">
+            <a:schemeClr val="accent1"/>
+          </a:fillRef>
+          <a:effectRef idx="1">
+            <a:schemeClr val="accent1"/>
+          </a:effectRef>
+          <a:fontRef idx="minor">
+            <a:schemeClr val="tx1"/>
+          </a:fontRef>
+        </p:style>
+      </p:cxnSp>
+      <p:sp>
+        <p:nvSpPr>
+          <p:cNvPr id="54" name="Diamond 53"/>
+          <p:cNvSpPr/>
+          <p:nvPr/>
+        </p:nvSpPr>
+        <p:spPr>
+          <a:xfrm>
+            <a:off x="5731136" y="4773168"/>
+            <a:ext cx="146304" cy="146304"/>
+          </a:xfrm>
+          <a:prstGeom prst="diamond">
+            <a:avLst/>
+          </a:prstGeom>
+          <a:solidFill>
+            <a:srgbClr val="9C4221"/>
+          </a:solidFill>
+          <a:ln>
+            <a:noFill/>
+          </a:ln>
+          <a:effectLst/>
+        </p:spPr>
+        <p:style>
+          <a:lnRef idx="1">
+            <a:schemeClr val="accent1"/>
+          </a:lnRef>
+          <a:fillRef idx="3">
+            <a:schemeClr val="accent1"/>
+          </a:fillRef>
+          <a:effectRef idx="2">
+            <a:schemeClr val="accent1"/>
+          </a:effectRef>
+          <a:fontRef idx="minor">
+            <a:schemeClr val="lt1"/>
+          </a:fontRef>
+        </p:style>
+        <p:txBody>
+          <a:bodyPr rtlCol="0" anchor="ctr"/>
+          <a:lstStyle/>
+          <a:p>
+            <a:pPr algn="ctr"/>
+          </a:p>
+        </p:txBody>
+      </p:sp>
+      <p:cxnSp>
+        <p:nvCxnSpPr>
+          <p:cNvPr id="55" name="Connector 54"/>
+          <p:cNvCxnSpPr/>
+          <p:nvPr/>
+        </p:nvCxnSpPr>
+        <p:spPr>
+          <a:xfrm>
+            <a:off x="8138697" y="1737360"/>
+            <a:ext cx="0" cy="2788920"/>
+          </a:xfrm>
+          <a:prstGeom prst="line">
+            <a:avLst/>
+          </a:prstGeom>
+          <a:ln w="15875">
+            <a:solidFill>
+              <a:srgbClr val="9C4221"/>
+            </a:solidFill>
+          </a:ln>
+        </p:spPr>
+        <p:style>
+          <a:lnRef idx="2">
+            <a:schemeClr val="accent1"/>
+          </a:lnRef>
+          <a:fillRef idx="0">
+            <a:schemeClr val="accent1"/>
+          </a:fillRef>
+          <a:effectRef idx="1">
+            <a:schemeClr val="accent1"/>
+          </a:effectRef>
+          <a:fontRef idx="minor">
+            <a:schemeClr val="tx1"/>
+          </a:fontRef>
+        </p:style>
+      </p:cxnSp>
+      <p:sp>
+        <p:nvSpPr>
+          <p:cNvPr id="56" name="Diamond 55"/>
+          <p:cNvSpPr/>
+          <p:nvPr/>
+        </p:nvSpPr>
+        <p:spPr>
+          <a:xfrm>
+            <a:off x="8065545" y="4773168"/>
+            <a:ext cx="146304" cy="146304"/>
+          </a:xfrm>
+          <a:prstGeom prst="diamond">
+            <a:avLst/>
+          </a:prstGeom>
+          <a:solidFill>
+            <a:srgbClr val="9C4221"/>
+          </a:solidFill>
+          <a:ln>
+            <a:noFill/>
+          </a:ln>
+          <a:effectLst/>
+        </p:spPr>
+        <p:style>
+          <a:lnRef idx="1">
+            <a:schemeClr val="accent1"/>
+          </a:lnRef>
+          <a:fillRef idx="3">
+            <a:schemeClr val="accent1"/>
+          </a:fillRef>
+          <a:effectRef idx="2">
+            <a:schemeClr val="accent1"/>
+          </a:effectRef>
+          <a:fontRef idx="minor">
+            <a:schemeClr val="lt1"/>
+          </a:fontRef>
+        </p:style>
+        <p:txBody>
+          <a:bodyPr rtlCol="0" anchor="ctr"/>
+          <a:lstStyle/>
+          <a:p>
+            <a:pPr algn="ctr"/>
+          </a:p>
+        </p:txBody>
+      </p:sp>
+      <p:cxnSp>
+        <p:nvCxnSpPr>
+          <p:cNvPr id="57" name="Connector 56"/>
+          <p:cNvCxnSpPr/>
+          <p:nvPr/>
+        </p:nvCxnSpPr>
+        <p:spPr>
+          <a:xfrm>
+            <a:off x="10589827" y="1737360"/>
+            <a:ext cx="0" cy="2788920"/>
+          </a:xfrm>
+          <a:prstGeom prst="line">
+            <a:avLst/>
+          </a:prstGeom>
+          <a:ln w="15875">
+            <a:solidFill>
+              <a:srgbClr val="9C4221"/>
+            </a:solidFill>
+          </a:ln>
+        </p:spPr>
+        <p:style>
+          <a:lnRef idx="2">
+            <a:schemeClr val="accent1"/>
+          </a:lnRef>
+          <a:fillRef idx="0">
+            <a:schemeClr val="accent1"/>
+          </a:fillRef>
+          <a:effectRef idx="1">
+            <a:schemeClr val="accent1"/>
+          </a:effectRef>
+          <a:fontRef idx="minor">
+            <a:schemeClr val="tx1"/>
+          </a:fontRef>
+        </p:style>
+      </p:cxnSp>
+      <p:sp>
+        <p:nvSpPr>
+          <p:cNvPr id="58" name="Diamond 57"/>
+          <p:cNvSpPr/>
+          <p:nvPr/>
+        </p:nvSpPr>
+        <p:spPr>
+          <a:xfrm>
+            <a:off x="10516675" y="4773168"/>
+            <a:ext cx="146304" cy="146304"/>
+          </a:xfrm>
+          <a:prstGeom prst="diamond">
+            <a:avLst/>
+          </a:prstGeom>
+          <a:solidFill>
+            <a:srgbClr val="9C4221"/>
+          </a:solidFill>
+          <a:ln>
+            <a:noFill/>
+          </a:ln>
+          <a:effectLst/>
+        </p:spPr>
+        <p:style>
+          <a:lnRef idx="1">
+            <a:schemeClr val="accent1"/>
+          </a:lnRef>
+          <a:fillRef idx="3">
+            <a:schemeClr val="accent1"/>
+          </a:fillRef>
+          <a:effectRef idx="2">
+            <a:schemeClr val="accent1"/>
+          </a:effectRef>
+          <a:fontRef idx="minor">
+            <a:schemeClr val="lt1"/>
+          </a:fontRef>
+        </p:style>
+        <p:txBody>
+          <a:bodyPr rtlCol="0" anchor="ctr"/>
+          <a:lstStyle/>
+          <a:p>
+            <a:pPr algn="ctr"/>
+          </a:p>
+        </p:txBody>
+      </p:sp>
+      <p:cxnSp>
+        <p:nvCxnSpPr>
+          <p:cNvPr id="59" name="Connector 58"/>
+          <p:cNvCxnSpPr/>
+          <p:nvPr/>
+        </p:nvCxnSpPr>
+        <p:spPr>
+          <a:xfrm>
+            <a:off x="11406871" y="1737360"/>
+            <a:ext cx="0" cy="2788920"/>
+          </a:xfrm>
+          <a:prstGeom prst="line">
+            <a:avLst/>
+          </a:prstGeom>
+          <a:ln w="15875">
+            <a:solidFill>
+              <a:srgbClr val="9C4221"/>
+            </a:solidFill>
+          </a:ln>
+        </p:spPr>
+        <p:style>
+          <a:lnRef idx="2">
+            <a:schemeClr val="accent1"/>
+          </a:lnRef>
+          <a:fillRef idx="0">
+            <a:schemeClr val="accent1"/>
+          </a:fillRef>
+          <a:effectRef idx="1">
+            <a:schemeClr val="accent1"/>
+          </a:effectRef>
+          <a:fontRef idx="minor">
+            <a:schemeClr val="tx1"/>
+          </a:fontRef>
+        </p:style>
+      </p:cxnSp>
+      <p:sp>
+        <p:nvSpPr>
+          <p:cNvPr id="60" name="Diamond 59"/>
+          <p:cNvSpPr/>
+          <p:nvPr/>
+        </p:nvSpPr>
+        <p:spPr>
+          <a:xfrm>
+            <a:off x="11333719" y="4773168"/>
+            <a:ext cx="146304" cy="146304"/>
+          </a:xfrm>
+          <a:prstGeom prst="diamond">
+            <a:avLst/>
+          </a:prstGeom>
+          <a:solidFill>
+            <a:srgbClr val="9C4221"/>
+          </a:solidFill>
+          <a:ln>
+            <a:noFill/>
+          </a:ln>
+          <a:effectLst/>
+        </p:spPr>
+        <p:style>
+          <a:lnRef idx="1">
+            <a:schemeClr val="accent1"/>
+          </a:lnRef>
+          <a:fillRef idx="3">
+            <a:schemeClr val="accent1"/>
+          </a:fillRef>
+          <a:effectRef idx="2">
+            <a:schemeClr val="accent1"/>
+          </a:effectRef>
+          <a:fontRef idx="minor">
+            <a:schemeClr val="lt1"/>
+          </a:fontRef>
+        </p:style>
+        <p:txBody>
+          <a:bodyPr rtlCol="0" anchor="ctr"/>
+          <a:lstStyle/>
+          <a:p>
+            <a:pPr algn="ctr"/>
+          </a:p>
+        </p:txBody>
+      </p:sp>
+      <p:sp>
+        <p:nvSpPr>
+          <p:cNvPr id="61" name="TextBox 60"/>
+          <p:cNvSpPr txBox="1"/>
+          <p:nvPr/>
+        </p:nvSpPr>
+        <p:spPr>
+          <a:xfrm>
+            <a:off x="548640" y="4745736"/>
+            <a:ext cx="3154680" cy="228600"/>
           </a:xfrm>
           <a:prstGeom prst="rect">
             <a:avLst/>
@@ -8062,7 +9137,466 @@
           <a:p>
             <a:pPr algn="l"/>
             <a:r>
-              <a:rPr sz="1500" b="1" i="0">
+              <a:rPr sz="1000" b="1" i="0">
+                <a:solidFill>
+                  <a:srgbClr val="9C4221"/>
+                </a:solidFill>
+                <a:latin typeface="Georgia"/>
+              </a:rPr>
+              <a:t>Course deadlines</a:t>
+            </a:r>
+          </a:p>
+        </p:txBody>
+      </p:sp>
+      <p:sp>
+        <p:nvSpPr>
+          <p:cNvPr id="62" name="TextBox 61"/>
+          <p:cNvSpPr txBox="1"/>
+          <p:nvPr/>
+        </p:nvSpPr>
+        <p:spPr>
+          <a:xfrm>
+            <a:off x="5347088" y="4937760"/>
+            <a:ext cx="914400" cy="201168"/>
+          </a:xfrm>
+          <a:prstGeom prst="rect">
+            <a:avLst/>
+          </a:prstGeom>
+          <a:noFill/>
+        </p:spPr>
+        <p:txBody>
+          <a:bodyPr wrap="square" lIns="0" rIns="0" tIns="0" bIns="0" anchor="t">
+            <a:spAutoFit/>
+          </a:bodyPr>
+          <a:lstStyle/>
+          <a:p>
+            <a:pPr algn="ctr"/>
+            <a:r>
+              <a:rPr sz="900" b="1" i="0">
+                <a:solidFill>
+                  <a:srgbClr val="9C4221"/>
+                </a:solidFill>
+                <a:latin typeface="Georgia"/>
+              </a:rPr>
+              <a:t>Oct 16</a:t>
+            </a:r>
+          </a:p>
+        </p:txBody>
+      </p:sp>
+      <p:sp>
+        <p:nvSpPr>
+          <p:cNvPr id="63" name="TextBox 62"/>
+          <p:cNvSpPr txBox="1"/>
+          <p:nvPr/>
+        </p:nvSpPr>
+        <p:spPr>
+          <a:xfrm>
+            <a:off x="7681497" y="4937760"/>
+            <a:ext cx="914400" cy="201168"/>
+          </a:xfrm>
+          <a:prstGeom prst="rect">
+            <a:avLst/>
+          </a:prstGeom>
+          <a:noFill/>
+        </p:spPr>
+        <p:txBody>
+          <a:bodyPr wrap="square" lIns="0" rIns="0" tIns="0" bIns="0" anchor="t">
+            <a:spAutoFit/>
+          </a:bodyPr>
+          <a:lstStyle/>
+          <a:p>
+            <a:pPr algn="ctr"/>
+            <a:r>
+              <a:rPr sz="900" b="1" i="0">
+                <a:solidFill>
+                  <a:srgbClr val="9C4221"/>
+                </a:solidFill>
+                <a:latin typeface="Georgia"/>
+              </a:rPr>
+              <a:t>Nov 5</a:t>
+            </a:r>
+          </a:p>
+        </p:txBody>
+      </p:sp>
+      <p:sp>
+        <p:nvSpPr>
+          <p:cNvPr id="64" name="TextBox 63"/>
+          <p:cNvSpPr txBox="1"/>
+          <p:nvPr/>
+        </p:nvSpPr>
+        <p:spPr>
+          <a:xfrm>
+            <a:off x="10132627" y="4937760"/>
+            <a:ext cx="914400" cy="201168"/>
+          </a:xfrm>
+          <a:prstGeom prst="rect">
+            <a:avLst/>
+          </a:prstGeom>
+          <a:noFill/>
+        </p:spPr>
+        <p:txBody>
+          <a:bodyPr wrap="square" lIns="0" rIns="0" tIns="0" bIns="0" anchor="t">
+            <a:spAutoFit/>
+          </a:bodyPr>
+          <a:lstStyle/>
+          <a:p>
+            <a:pPr algn="ctr"/>
+            <a:r>
+              <a:rPr sz="900" b="1" i="0">
+                <a:solidFill>
+                  <a:srgbClr val="9C4221"/>
+                </a:solidFill>
+                <a:latin typeface="Georgia"/>
+              </a:rPr>
+              <a:t>Nov 26</a:t>
+            </a:r>
+          </a:p>
+        </p:txBody>
+      </p:sp>
+      <p:sp>
+        <p:nvSpPr>
+          <p:cNvPr id="65" name="TextBox 64"/>
+          <p:cNvSpPr txBox="1"/>
+          <p:nvPr/>
+        </p:nvSpPr>
+        <p:spPr>
+          <a:xfrm>
+            <a:off x="10949671" y="4937760"/>
+            <a:ext cx="914400" cy="201168"/>
+          </a:xfrm>
+          <a:prstGeom prst="rect">
+            <a:avLst/>
+          </a:prstGeom>
+          <a:noFill/>
+        </p:spPr>
+        <p:txBody>
+          <a:bodyPr wrap="square" lIns="0" rIns="0" tIns="0" bIns="0" anchor="t">
+            <a:spAutoFit/>
+          </a:bodyPr>
+          <a:lstStyle/>
+          <a:p>
+            <a:pPr algn="ctr"/>
+            <a:r>
+              <a:rPr sz="900" b="1" i="0">
+                <a:solidFill>
+                  <a:srgbClr val="9C4221"/>
+                </a:solidFill>
+                <a:latin typeface="Georgia"/>
+              </a:rPr>
+              <a:t>Dec 3</a:t>
+            </a:r>
+          </a:p>
+        </p:txBody>
+      </p:sp>
+      <p:sp>
+        <p:nvSpPr>
+          <p:cNvPr id="66" name="Rounded Rectangle 65"/>
+          <p:cNvSpPr/>
+          <p:nvPr/>
+        </p:nvSpPr>
+        <p:spPr>
+          <a:xfrm>
+            <a:off x="548640" y="5376672"/>
+            <a:ext cx="3575304" cy="841248"/>
+          </a:xfrm>
+          <a:prstGeom prst="roundRect">
+            <a:avLst>
+              <a:gd name="adj" fmla="val 8000"/>
+            </a:avLst>
+          </a:prstGeom>
+          <a:solidFill>
+            <a:srgbClr val="ECEFEB"/>
+          </a:solidFill>
+          <a:ln w="12700">
+            <a:solidFill>
+              <a:srgbClr val="5E7A5A"/>
+            </a:solidFill>
+          </a:ln>
+          <a:effectLst/>
+        </p:spPr>
+        <p:style>
+          <a:lnRef idx="1">
+            <a:schemeClr val="accent1"/>
+          </a:lnRef>
+          <a:fillRef idx="3">
+            <a:schemeClr val="accent1"/>
+          </a:fillRef>
+          <a:effectRef idx="2">
+            <a:schemeClr val="accent1"/>
+          </a:effectRef>
+          <a:fontRef idx="minor">
+            <a:schemeClr val="lt1"/>
+          </a:fontRef>
+        </p:style>
+        <p:txBody>
+          <a:bodyPr rtlCol="0" anchor="ctr"/>
+          <a:lstStyle/>
+          <a:p>
+            <a:pPr algn="ctr"/>
+          </a:p>
+        </p:txBody>
+      </p:sp>
+      <p:sp>
+        <p:nvSpPr>
+          <p:cNvPr id="67" name="TextBox 66"/>
+          <p:cNvSpPr txBox="1"/>
+          <p:nvPr/>
+        </p:nvSpPr>
+        <p:spPr>
+          <a:xfrm>
+            <a:off x="685800" y="5468112"/>
+            <a:ext cx="3300984" cy="274320"/>
+          </a:xfrm>
+          <a:prstGeom prst="rect">
+            <a:avLst/>
+          </a:prstGeom>
+          <a:noFill/>
+        </p:spPr>
+        <p:txBody>
+          <a:bodyPr wrap="square" lIns="0" rIns="0" tIns="0" bIns="0" anchor="t">
+            <a:spAutoFit/>
+          </a:bodyPr>
+          <a:lstStyle/>
+          <a:p>
+            <a:pPr algn="l"/>
+            <a:r>
+              <a:rPr sz="1300" b="1" i="0">
+                <a:solidFill>
+                  <a:srgbClr val="15140F"/>
+                </a:solidFill>
+                <a:latin typeface="Georgia"/>
+              </a:rPr>
+              <a:t>Ihsan Salari</a:t>
+            </a:r>
+          </a:p>
+        </p:txBody>
+      </p:sp>
+      <p:sp>
+        <p:nvSpPr>
+          <p:cNvPr id="68" name="TextBox 67"/>
+          <p:cNvSpPr txBox="1"/>
+          <p:nvPr/>
+        </p:nvSpPr>
+        <p:spPr>
+          <a:xfrm>
+            <a:off x="685800" y="5760720"/>
+            <a:ext cx="3300984" cy="548640"/>
+          </a:xfrm>
+          <a:prstGeom prst="rect">
+            <a:avLst/>
+          </a:prstGeom>
+          <a:noFill/>
+        </p:spPr>
+        <p:txBody>
+          <a:bodyPr wrap="square" lIns="0" rIns="0" tIns="0" bIns="0" anchor="t">
+            <a:spAutoFit/>
+          </a:bodyPr>
+          <a:lstStyle/>
+          <a:p>
+            <a:pPr algn="l"/>
+            <a:r>
+              <a:rPr sz="1100" b="0" i="0">
+                <a:solidFill>
+                  <a:srgbClr val="15140F"/>
+                </a:solidFill>
+                <a:latin typeface="Georgia"/>
+              </a:rPr>
+              <a:t>Detect and filter: PFD, charge pump, loop filter</a:t>
+            </a:r>
+          </a:p>
+        </p:txBody>
+      </p:sp>
+      <p:sp>
+        <p:nvSpPr>
+          <p:cNvPr id="69" name="Rounded Rectangle 68"/>
+          <p:cNvSpPr/>
+          <p:nvPr/>
+        </p:nvSpPr>
+        <p:spPr>
+          <a:xfrm>
+            <a:off x="4306824" y="5376672"/>
+            <a:ext cx="3575304" cy="841248"/>
+          </a:xfrm>
+          <a:prstGeom prst="roundRect">
+            <a:avLst>
+              <a:gd name="adj" fmla="val 8000"/>
+            </a:avLst>
+          </a:prstGeom>
+          <a:solidFill>
+            <a:srgbClr val="F0EADE"/>
+          </a:solidFill>
+          <a:ln w="12700">
+            <a:solidFill>
+              <a:srgbClr val="77716A"/>
+            </a:solidFill>
+          </a:ln>
+          <a:effectLst/>
+        </p:spPr>
+        <p:style>
+          <a:lnRef idx="1">
+            <a:schemeClr val="accent1"/>
+          </a:lnRef>
+          <a:fillRef idx="3">
+            <a:schemeClr val="accent1"/>
+          </a:fillRef>
+          <a:effectRef idx="2">
+            <a:schemeClr val="accent1"/>
+          </a:effectRef>
+          <a:fontRef idx="minor">
+            <a:schemeClr val="lt1"/>
+          </a:fontRef>
+        </p:style>
+        <p:txBody>
+          <a:bodyPr rtlCol="0" anchor="ctr"/>
+          <a:lstStyle/>
+          <a:p>
+            <a:pPr algn="ctr"/>
+          </a:p>
+        </p:txBody>
+      </p:sp>
+      <p:sp>
+        <p:nvSpPr>
+          <p:cNvPr id="70" name="TextBox 69"/>
+          <p:cNvSpPr txBox="1"/>
+          <p:nvPr/>
+        </p:nvSpPr>
+        <p:spPr>
+          <a:xfrm>
+            <a:off x="4443984" y="5468112"/>
+            <a:ext cx="3300984" cy="274320"/>
+          </a:xfrm>
+          <a:prstGeom prst="rect">
+            <a:avLst/>
+          </a:prstGeom>
+          <a:noFill/>
+        </p:spPr>
+        <p:txBody>
+          <a:bodyPr wrap="square" lIns="0" rIns="0" tIns="0" bIns="0" anchor="t">
+            <a:spAutoFit/>
+          </a:bodyPr>
+          <a:lstStyle/>
+          <a:p>
+            <a:pPr algn="l"/>
+            <a:r>
+              <a:rPr sz="1300" b="1" i="0">
+                <a:solidFill>
+                  <a:srgbClr val="15140F"/>
+                </a:solidFill>
+                <a:latin typeface="Georgia"/>
+              </a:rPr>
+              <a:t>Dhyey Bhatt</a:t>
+            </a:r>
+          </a:p>
+        </p:txBody>
+      </p:sp>
+      <p:sp>
+        <p:nvSpPr>
+          <p:cNvPr id="71" name="TextBox 70"/>
+          <p:cNvSpPr txBox="1"/>
+          <p:nvPr/>
+        </p:nvSpPr>
+        <p:spPr>
+          <a:xfrm>
+            <a:off x="4443984" y="5760720"/>
+            <a:ext cx="3300984" cy="548640"/>
+          </a:xfrm>
+          <a:prstGeom prst="rect">
+            <a:avLst/>
+          </a:prstGeom>
+          <a:noFill/>
+        </p:spPr>
+        <p:txBody>
+          <a:bodyPr wrap="square" lIns="0" rIns="0" tIns="0" bIns="0" anchor="t">
+            <a:spAutoFit/>
+          </a:bodyPr>
+          <a:lstStyle/>
+          <a:p>
+            <a:pPr algn="l"/>
+            <a:r>
+              <a:rPr sz="1100" b="0" i="0">
+                <a:solidFill>
+                  <a:srgbClr val="15140F"/>
+                </a:solidFill>
+                <a:latin typeface="Georgia"/>
+              </a:rPr>
+              <a:t>Oscillate and divide: VCO, prescaler, divider, lock detector</a:t>
+            </a:r>
+          </a:p>
+        </p:txBody>
+      </p:sp>
+      <p:sp>
+        <p:nvSpPr>
+          <p:cNvPr id="72" name="Rounded Rectangle 71"/>
+          <p:cNvSpPr/>
+          <p:nvPr/>
+        </p:nvSpPr>
+        <p:spPr>
+          <a:xfrm>
+            <a:off x="8065008" y="5376672"/>
+            <a:ext cx="3575304" cy="841248"/>
+          </a:xfrm>
+          <a:prstGeom prst="roundRect">
+            <a:avLst>
+              <a:gd name="adj" fmla="val 8000"/>
+            </a:avLst>
+          </a:prstGeom>
+          <a:solidFill>
+            <a:srgbClr val="EAEDF1"/>
+          </a:solidFill>
+          <a:ln w="12700">
+            <a:solidFill>
+              <a:srgbClr val="4F6D8A"/>
+            </a:solidFill>
+          </a:ln>
+          <a:effectLst/>
+        </p:spPr>
+        <p:style>
+          <a:lnRef idx="1">
+            <a:schemeClr val="accent1"/>
+          </a:lnRef>
+          <a:fillRef idx="3">
+            <a:schemeClr val="accent1"/>
+          </a:fillRef>
+          <a:effectRef idx="2">
+            <a:schemeClr val="accent1"/>
+          </a:effectRef>
+          <a:fontRef idx="minor">
+            <a:schemeClr val="lt1"/>
+          </a:fontRef>
+        </p:style>
+        <p:txBody>
+          <a:bodyPr rtlCol="0" anchor="ctr"/>
+          <a:lstStyle/>
+          <a:p>
+            <a:pPr algn="ctr"/>
+          </a:p>
+        </p:txBody>
+      </p:sp>
+      <p:sp>
+        <p:nvSpPr>
+          <p:cNvPr id="73" name="TextBox 72"/>
+          <p:cNvSpPr txBox="1"/>
+          <p:nvPr/>
+        </p:nvSpPr>
+        <p:spPr>
+          <a:xfrm>
+            <a:off x="8202168" y="5468112"/>
+            <a:ext cx="3300984" cy="274320"/>
+          </a:xfrm>
+          <a:prstGeom prst="rect">
+            <a:avLst/>
+          </a:prstGeom>
+          <a:noFill/>
+        </p:spPr>
+        <p:txBody>
+          <a:bodyPr wrap="square" lIns="0" rIns="0" tIns="0" bIns="0" anchor="t">
+            <a:spAutoFit/>
+          </a:bodyPr>
+          <a:lstStyle/>
+          <a:p>
+            <a:pPr algn="l"/>
+            <a:r>
+              <a:rPr sz="1300" b="1" i="0">
                 <a:solidFill>
                   <a:srgbClr val="15140F"/>
                 </a:solidFill>
@@ -8075,14 +9609,14 @@
       </p:sp>
       <p:sp>
         <p:nvSpPr>
-          <p:cNvPr id="32" name="TextBox 31"/>
+          <p:cNvPr id="74" name="TextBox 73"/>
           <p:cNvSpPr txBox="1"/>
           <p:nvPr/>
         </p:nvSpPr>
         <p:spPr>
           <a:xfrm>
-            <a:off x="9601200" y="4809744"/>
-            <a:ext cx="1874519" cy="274320"/>
+            <a:off x="8202168" y="5760720"/>
+            <a:ext cx="3300984" cy="548640"/>
           </a:xfrm>
           <a:prstGeom prst="rect">
             <a:avLst/>
@@ -8095,74 +9629,15 @@
           </a:bodyPr>
           <a:lstStyle/>
           <a:p>
-            <a:pPr algn="r"/>
-            <a:r>
-              <a:rPr sz="1100" b="1" i="0">
-                <a:solidFill>
-                  <a:srgbClr val="4F6D8A"/>
+            <a:pPr algn="l"/>
+            <a:r>
+              <a:rPr sz="1100" b="0" i="0">
+                <a:solidFill>
+                  <a:srgbClr val="15140F"/>
                 </a:solidFill>
                 <a:latin typeface="Georgia"/>
               </a:rPr>
-              <a:t>TOGETHER</a:t>
-            </a:r>
-          </a:p>
-        </p:txBody>
-      </p:sp>
-      <p:sp>
-        <p:nvSpPr>
-          <p:cNvPr id="33" name="TextBox 32"/>
-          <p:cNvSpPr txBox="1"/>
-          <p:nvPr/>
-        </p:nvSpPr>
-        <p:spPr>
-          <a:xfrm>
-            <a:off x="6583680" y="5084064"/>
-            <a:ext cx="4892040" cy="548640"/>
-          </a:xfrm>
-          <a:prstGeom prst="rect">
-            <a:avLst/>
-          </a:prstGeom>
-          <a:noFill/>
-        </p:spPr>
-        <p:txBody>
-          <a:bodyPr wrap="square" lIns="0" rIns="0" tIns="0" bIns="0" anchor="t">
-            <a:spAutoFit/>
-          </a:bodyPr>
-          <a:lstStyle/>
-          <a:p>
-            <a:pPr algn="l" marL="228600" indent="-228600">
-              <a:buClr>
-                <a:srgbClr val="4F6D8A"/>
-              </a:buClr>
-              <a:buFont typeface="Arial"/>
-              <a:buChar char="•"/>
-            </a:pPr>
-            <a:r>
-              <a:rPr sz="1200" b="0" i="0">
-                <a:solidFill>
-                  <a:srgbClr val="15140F"/>
-                </a:solidFill>
-                <a:latin typeface="Georgia"/>
-              </a:rPr>
-              <a:t>Top-level integration and full-loop simulation</a:t>
-            </a:r>
-          </a:p>
-          <a:p>
-            <a:pPr algn="l" marL="228600" indent="-228600">
-              <a:buClr>
-                <a:srgbClr val="4F6D8A"/>
-              </a:buClr>
-              <a:buFont typeface="Arial"/>
-              <a:buChar char="•"/>
-            </a:pPr>
-            <a:r>
-              <a:rPr sz="1200" b="0" i="0">
-                <a:solidFill>
-                  <a:srgbClr val="15140F"/>
-                </a:solidFill>
-                <a:latin typeface="Georgia"/>
-              </a:rPr>
-              <a:t>Documentation, GitHub and presentations</a:t>
+              <a:t>Loop model, integration, full-loop simulation, docs</a:t>
             </a:r>
           </a:p>
         </p:txBody>

</xml_diff>

<commit_message>
Slides: add how we test the whole loop to slide 1
Also keeps the research behind it in proposal/src/system-test-research.md.

Co-Authored-By: Claude Opus 5.5 (1M context) <noreply@anthropic.com>
</commit_message>
<xml_diff>
--- a/proposal/ece298a_pll_proposal_slides.pptx
+++ b/proposal/ece298a_pll_proposal_slides.pptx
@@ -3317,7 +3317,7 @@
         <p:spPr>
           <a:xfrm>
             <a:off x="548640" y="1938528"/>
-            <a:ext cx="3931920" cy="4206240"/>
+            <a:ext cx="3931920" cy="2011680"/>
           </a:xfrm>
           <a:prstGeom prst="rect">
             <a:avLst/>
@@ -3347,7 +3347,7 @@
                 </a:solidFill>
                 <a:latin typeface="Georgia"/>
               </a:rPr>
-              <a:t>Build a classic charge-pump phase-locked loop: a clock multiplier, the standard circuit every chip uses to make a fast clock from a slow one.</a:t>
+              <a:t>Build a charge-pump PLL: the clock multiplier every chip uses to make a fast clock from a slow one.</a:t>
             </a:r>
           </a:p>
           <a:p>
@@ -3368,7 +3368,7 @@
                 </a:solidFill>
                 <a:latin typeface="Georgia"/>
               </a:rPr>
-              <a:t>It multiplies a 5 to 12.5 MHz reference by 8N (N = 1 to 5) onto a 50 to 200 MHz on-chip oscillator.</a:t>
+              <a:t>Multiply a 5 to 12.5 MHz reference by 8N (N = 1 to 5) onto a 50 to 200 MHz on-chip VCO.</a:t>
             </a:r>
           </a:p>
           <a:p>
@@ -3389,13 +3389,71 @@
                 </a:solidFill>
                 <a:latin typeface="Georgia"/>
               </a:rPr>
-              <a:t>Mixed-signal by design: the phase detector and dividers are standard-cell logic, and the charge pump, loop filter and VCO are transistor-level analog.</a:t>
-            </a:r>
-          </a:p>
+              <a:t>Mixed-signal: a standard-cell PFD and dividers around a transistor-level pump, filter and VCO.</a:t>
+            </a:r>
+          </a:p>
+        </p:txBody>
+      </p:sp>
+      <p:sp>
+        <p:nvSpPr>
+          <p:cNvPr id="9" name="TextBox 8"/>
+          <p:cNvSpPr txBox="1"/>
+          <p:nvPr/>
+        </p:nvSpPr>
+        <p:spPr>
+          <a:xfrm>
+            <a:off x="548640" y="4114800"/>
+            <a:ext cx="3931920" cy="292608"/>
+          </a:xfrm>
+          <a:prstGeom prst="rect">
+            <a:avLst/>
+          </a:prstGeom>
+          <a:noFill/>
+        </p:spPr>
+        <p:txBody>
+          <a:bodyPr wrap="square" lIns="0" rIns="0" tIns="0" bIns="0" anchor="t">
+            <a:spAutoFit/>
+          </a:bodyPr>
+          <a:lstStyle/>
+          <a:p>
+            <a:pPr algn="l"/>
+            <a:r>
+              <a:rPr sz="1600" b="1" i="0">
+                <a:solidFill>
+                  <a:srgbClr val="15140F"/>
+                </a:solidFill>
+                <a:latin typeface="Georgia"/>
+              </a:rPr>
+              <a:t>Testing the whole loop</a:t>
+            </a:r>
+          </a:p>
+        </p:txBody>
+      </p:sp>
+      <p:sp>
+        <p:nvSpPr>
+          <p:cNvPr id="10" name="TextBox 9"/>
+          <p:cNvSpPr txBox="1"/>
+          <p:nvPr/>
+        </p:nvSpPr>
+        <p:spPr>
+          <a:xfrm>
+            <a:off x="548640" y="4526280"/>
+            <a:ext cx="3931920" cy="1737360"/>
+          </a:xfrm>
+          <a:prstGeom prst="rect">
+            <a:avLst/>
+          </a:prstGeom>
+          <a:noFill/>
+        </p:spPr>
+        <p:txBody>
+          <a:bodyPr wrap="square" lIns="0" rIns="0" tIns="0" bIns="0" anchor="t">
+            <a:spAutoFit/>
+          </a:bodyPr>
+          <a:lstStyle/>
           <a:p>
             <a:pPr algn="l" marL="228600" indent="-228600">
               <a:spcAft>
-                <a:spcPts val="900"/>
+                <a:spcPts val="500"/>
               </a:spcAft>
               <a:buClr>
                 <a:srgbClr val="9C4221"/>
@@ -3404,20 +3462,83 @@
               <a:buChar char="•"/>
             </a:pPr>
             <a:r>
-              <a:rPr sz="1400" b="0" i="0">
+              <a:rPr sz="1200" b="0" i="0">
                 <a:solidFill>
                   <a:srgbClr val="15140F"/>
                 </a:solidFill>
                 <a:latin typeface="Georgia"/>
               </a:rPr>
-              <a:t>It exercises the whole open-source flow: RTL and CocoTB, ngspice across corners, layout with DRC and LVS.</a:t>
-            </a:r>
-          </a:p>
-        </p:txBody>
-      </p:sp>
-      <p:sp>
-        <p:nvSpPr>
-          <p:cNvPr id="9" name="TextBox 8"/>
+              <a:t>Linear model (python-control, ngspice AC): margin, bandwidth, lock time</a:t>
+            </a:r>
+          </a:p>
+          <a:p>
+            <a:pPr algn="l" marL="228600" indent="-228600">
+              <a:spcAft>
+                <a:spcPts val="500"/>
+              </a:spcAft>
+              <a:buClr>
+                <a:srgbClr val="9C4221"/>
+              </a:buClr>
+              <a:buFont typeface="Arial"/>
+              <a:buChar char="•"/>
+            </a:pPr>
+            <a:r>
+              <a:rPr sz="1200" b="0" i="0">
+                <a:solidFill>
+                  <a:srgbClr val="15140F"/>
+                </a:solidFill>
+                <a:latin typeface="Georgia"/>
+              </a:rPr>
+              <a:t>Real RTL in cocotb with a Python pump, filter and VCO: locks at every N</a:t>
+            </a:r>
+          </a:p>
+          <a:p>
+            <a:pPr algn="l" marL="228600" indent="-228600">
+              <a:spcAft>
+                <a:spcPts val="500"/>
+              </a:spcAft>
+              <a:buClr>
+                <a:srgbClr val="9C4221"/>
+              </a:buClr>
+              <a:buFont typeface="Arial"/>
+              <a:buChar char="•"/>
+            </a:pPr>
+            <a:r>
+              <a:rPr sz="1200" b="0" i="0">
+                <a:solidFill>
+                  <a:srgbClr val="15140F"/>
+                </a:solidFill>
+                <a:latin typeface="Georgia"/>
+              </a:rPr>
+              <a:t>Co-simulation (cocotbext-ams): RTL with the transistor pump and filter</a:t>
+            </a:r>
+          </a:p>
+          <a:p>
+            <a:pPr algn="l" marL="228600" indent="-228600">
+              <a:spcAft>
+                <a:spcPts val="500"/>
+              </a:spcAft>
+              <a:buClr>
+                <a:srgbClr val="9C4221"/>
+              </a:buClr>
+              <a:buFont typeface="Arial"/>
+              <a:buChar char="•"/>
+            </a:pPr>
+            <a:r>
+              <a:rPr sz="1200" b="0" i="0">
+                <a:solidFill>
+                  <a:srgbClr val="15140F"/>
+                </a:solidFill>
+                <a:latin typeface="Georgia"/>
+              </a:rPr>
+              <a:t>Transistor loop in ngspice from near lock, plus one overnight lock run</a:t>
+            </a:r>
+          </a:p>
+        </p:txBody>
+      </p:sp>
+      <p:sp>
+        <p:nvSpPr>
+          <p:cNvPr id="11" name="TextBox 10"/>
           <p:cNvSpPr txBox="1"/>
           <p:nvPr/>
         </p:nvSpPr>
@@ -3452,7 +3573,7 @@
       </p:sp>
       <p:sp>
         <p:nvSpPr>
-          <p:cNvPr id="10" name="Rounded Rectangle 9"/>
+          <p:cNvPr id="12" name="Rounded Rectangle 11"/>
           <p:cNvSpPr/>
           <p:nvPr/>
         </p:nvSpPr>
@@ -3533,7 +3654,7 @@
       </p:sp>
       <p:sp>
         <p:nvSpPr>
-          <p:cNvPr id="11" name="Rounded Rectangle 10"/>
+          <p:cNvPr id="13" name="Rounded Rectangle 12"/>
           <p:cNvSpPr/>
           <p:nvPr/>
         </p:nvSpPr>
@@ -3614,7 +3735,7 @@
       </p:sp>
       <p:sp>
         <p:nvSpPr>
-          <p:cNvPr id="12" name="Rounded Rectangle 11"/>
+          <p:cNvPr id="14" name="Rounded Rectangle 13"/>
           <p:cNvSpPr/>
           <p:nvPr/>
         </p:nvSpPr>
@@ -3695,7 +3816,7 @@
       </p:sp>
       <p:sp>
         <p:nvSpPr>
-          <p:cNvPr id="13" name="Rounded Rectangle 12"/>
+          <p:cNvPr id="15" name="Rounded Rectangle 14"/>
           <p:cNvSpPr/>
           <p:nvPr/>
         </p:nvSpPr>
@@ -3776,7 +3897,7 @@
       </p:sp>
       <p:sp>
         <p:nvSpPr>
-          <p:cNvPr id="14" name="Rounded Rectangle 13"/>
+          <p:cNvPr id="16" name="Rounded Rectangle 15"/>
           <p:cNvSpPr/>
           <p:nvPr/>
         </p:nvSpPr>
@@ -3857,7 +3978,7 @@
       </p:sp>
       <p:sp>
         <p:nvSpPr>
-          <p:cNvPr id="15" name="Rounded Rectangle 14"/>
+          <p:cNvPr id="17" name="Rounded Rectangle 16"/>
           <p:cNvSpPr/>
           <p:nvPr/>
         </p:nvSpPr>
@@ -3938,7 +4059,7 @@
       </p:sp>
       <p:sp>
         <p:nvSpPr>
-          <p:cNvPr id="16" name="Rounded Rectangle 15"/>
+          <p:cNvPr id="18" name="Rounded Rectangle 17"/>
           <p:cNvSpPr/>
           <p:nvPr/>
         </p:nvSpPr>
@@ -4019,7 +4140,7 @@
       </p:sp>
       <p:sp>
         <p:nvSpPr>
-          <p:cNvPr id="17" name="Rounded Rectangle 16"/>
+          <p:cNvPr id="19" name="Rounded Rectangle 18"/>
           <p:cNvSpPr/>
           <p:nvPr/>
         </p:nvSpPr>
@@ -4100,85 +4221,13 @@
       </p:sp>
       <p:cxnSp>
         <p:nvCxnSpPr>
-          <p:cNvPr id="18" name="Connector 17"/>
-          <p:cNvCxnSpPr/>
-          <p:nvPr/>
-        </p:nvCxnSpPr>
-        <p:spPr>
-          <a:xfrm>
-            <a:off x="6309360" y="2400300"/>
-            <a:ext cx="347472" cy="0"/>
-          </a:xfrm>
-          <a:prstGeom prst="line">
-            <a:avLst/>
-          </a:prstGeom>
-          <a:ln w="15875">
-            <a:solidFill>
-              <a:srgbClr val="77716A"/>
-            </a:solidFill>
-            <a:tailEnd type="triangle" w="med" len="med"/>
-          </a:ln>
-        </p:spPr>
-        <p:style>
-          <a:lnRef idx="2">
-            <a:schemeClr val="accent1"/>
-          </a:lnRef>
-          <a:fillRef idx="0">
-            <a:schemeClr val="accent1"/>
-          </a:fillRef>
-          <a:effectRef idx="1">
-            <a:schemeClr val="accent1"/>
-          </a:effectRef>
-          <a:fontRef idx="minor">
-            <a:schemeClr val="tx1"/>
-          </a:fontRef>
-        </p:style>
-      </p:cxnSp>
-      <p:cxnSp>
-        <p:nvCxnSpPr>
-          <p:cNvPr id="19" name="Connector 18"/>
-          <p:cNvCxnSpPr/>
-          <p:nvPr/>
-        </p:nvCxnSpPr>
-        <p:spPr>
-          <a:xfrm>
-            <a:off x="8138160" y="2400300"/>
-            <a:ext cx="347472" cy="0"/>
-          </a:xfrm>
-          <a:prstGeom prst="line">
-            <a:avLst/>
-          </a:prstGeom>
-          <a:ln w="15875">
-            <a:solidFill>
-              <a:srgbClr val="77716A"/>
-            </a:solidFill>
-            <a:tailEnd type="triangle" w="med" len="med"/>
-          </a:ln>
-        </p:spPr>
-        <p:style>
-          <a:lnRef idx="2">
-            <a:schemeClr val="accent1"/>
-          </a:lnRef>
-          <a:fillRef idx="0">
-            <a:schemeClr val="accent1"/>
-          </a:fillRef>
-          <a:effectRef idx="1">
-            <a:schemeClr val="accent1"/>
-          </a:effectRef>
-          <a:fontRef idx="minor">
-            <a:schemeClr val="tx1"/>
-          </a:fontRef>
-        </p:style>
-      </p:cxnSp>
-      <p:cxnSp>
-        <p:nvCxnSpPr>
           <p:cNvPr id="20" name="Connector 19"/>
           <p:cNvCxnSpPr/>
           <p:nvPr/>
         </p:nvCxnSpPr>
         <p:spPr>
           <a:xfrm>
-            <a:off x="9966960" y="2400300"/>
+            <a:off x="6309360" y="2400300"/>
             <a:ext cx="347472" cy="0"/>
           </a:xfrm>
           <a:prstGeom prst="line">
@@ -4214,79 +4263,8 @@
         </p:nvCxnSpPr>
         <p:spPr>
           <a:xfrm>
-            <a:off x="11064240" y="2834639"/>
-            <a:ext cx="0" cy="393193"/>
-          </a:xfrm>
-          <a:prstGeom prst="line">
-            <a:avLst/>
-          </a:prstGeom>
-          <a:ln w="15875">
-            <a:solidFill>
-              <a:srgbClr val="77716A"/>
-            </a:solidFill>
-            <a:tailEnd type="triangle" w="med" len="med"/>
-          </a:ln>
-        </p:spPr>
-        <p:style>
-          <a:lnRef idx="2">
-            <a:schemeClr val="accent1"/>
-          </a:lnRef>
-          <a:fillRef idx="0">
-            <a:schemeClr val="accent1"/>
-          </a:fillRef>
-          <a:effectRef idx="1">
-            <a:schemeClr val="accent1"/>
-          </a:effectRef>
-          <a:fontRef idx="minor">
-            <a:schemeClr val="tx1"/>
-          </a:fontRef>
-        </p:style>
-      </p:cxnSp>
-      <p:sp>
-        <p:nvSpPr>
-          <p:cNvPr id="22" name="TextBox 21"/>
-          <p:cNvSpPr txBox="1"/>
-          <p:nvPr/>
-        </p:nvSpPr>
-        <p:spPr>
-          <a:xfrm>
-            <a:off x="11137392" y="2944368"/>
-            <a:ext cx="731520" cy="228600"/>
-          </a:xfrm>
-          <a:prstGeom prst="rect">
-            <a:avLst/>
-          </a:prstGeom>
-          <a:noFill/>
-        </p:spPr>
-        <p:txBody>
-          <a:bodyPr wrap="square" lIns="0" rIns="0" tIns="0" bIns="0" anchor="t">
-            <a:spAutoFit/>
-          </a:bodyPr>
-          <a:lstStyle/>
-          <a:p>
-            <a:pPr algn="l"/>
-            <a:r>
-              <a:rPr sz="1100" b="0" i="1">
-                <a:solidFill>
-                  <a:srgbClr val="4A4740"/>
-                </a:solidFill>
-                <a:latin typeface="Georgia"/>
-              </a:rPr>
-              <a:t>Vctrl</a:t>
-            </a:r>
-          </a:p>
-        </p:txBody>
-      </p:sp>
-      <p:cxnSp>
-        <p:nvCxnSpPr>
-          <p:cNvPr id="23" name="Connector 22"/>
-          <p:cNvCxnSpPr/>
-          <p:nvPr/>
-        </p:nvCxnSpPr>
-        <p:spPr>
-          <a:xfrm>
-            <a:off x="11064240" y="4114800"/>
-            <a:ext cx="0" cy="393192"/>
+            <a:off x="8138160" y="2400300"/>
+            <a:ext cx="347472" cy="0"/>
           </a:xfrm>
           <a:prstGeom prst="line">
             <a:avLst/>
@@ -4315,14 +4293,14 @@
       </p:cxnSp>
       <p:cxnSp>
         <p:nvCxnSpPr>
-          <p:cNvPr id="24" name="Connector 23"/>
+          <p:cNvPr id="22" name="Connector 21"/>
           <p:cNvCxnSpPr/>
           <p:nvPr/>
         </p:nvCxnSpPr>
         <p:spPr>
           <a:xfrm>
-            <a:off x="7406640" y="2834639"/>
-            <a:ext cx="0" cy="393193"/>
+            <a:off x="9966960" y="2400300"/>
+            <a:ext cx="347472" cy="0"/>
           </a:xfrm>
           <a:prstGeom prst="line">
             <a:avLst/>
@@ -4351,14 +4329,14 @@
       </p:cxnSp>
       <p:cxnSp>
         <p:nvCxnSpPr>
-          <p:cNvPr id="25" name="Connector 24"/>
+          <p:cNvPr id="23" name="Connector 22"/>
           <p:cNvCxnSpPr/>
           <p:nvPr/>
         </p:nvCxnSpPr>
         <p:spPr>
-          <a:xfrm flipH="1">
-            <a:off x="9235440" y="4960620"/>
-            <a:ext cx="1097280" cy="0"/>
+          <a:xfrm>
+            <a:off x="11064240" y="2834639"/>
+            <a:ext cx="0" cy="393193"/>
           </a:xfrm>
           <a:prstGeom prst="line">
             <a:avLst/>
@@ -4367,6 +4345,78 @@
             <a:solidFill>
               <a:srgbClr val="77716A"/>
             </a:solidFill>
+            <a:tailEnd type="triangle" w="med" len="med"/>
+          </a:ln>
+        </p:spPr>
+        <p:style>
+          <a:lnRef idx="2">
+            <a:schemeClr val="accent1"/>
+          </a:lnRef>
+          <a:fillRef idx="0">
+            <a:schemeClr val="accent1"/>
+          </a:fillRef>
+          <a:effectRef idx="1">
+            <a:schemeClr val="accent1"/>
+          </a:effectRef>
+          <a:fontRef idx="minor">
+            <a:schemeClr val="tx1"/>
+          </a:fontRef>
+        </p:style>
+      </p:cxnSp>
+      <p:sp>
+        <p:nvSpPr>
+          <p:cNvPr id="24" name="TextBox 23"/>
+          <p:cNvSpPr txBox="1"/>
+          <p:nvPr/>
+        </p:nvSpPr>
+        <p:spPr>
+          <a:xfrm>
+            <a:off x="11137392" y="2944368"/>
+            <a:ext cx="731520" cy="228600"/>
+          </a:xfrm>
+          <a:prstGeom prst="rect">
+            <a:avLst/>
+          </a:prstGeom>
+          <a:noFill/>
+        </p:spPr>
+        <p:txBody>
+          <a:bodyPr wrap="square" lIns="0" rIns="0" tIns="0" bIns="0" anchor="t">
+            <a:spAutoFit/>
+          </a:bodyPr>
+          <a:lstStyle/>
+          <a:p>
+            <a:pPr algn="l"/>
+            <a:r>
+              <a:rPr sz="1100" b="0" i="1">
+                <a:solidFill>
+                  <a:srgbClr val="4A4740"/>
+                </a:solidFill>
+                <a:latin typeface="Georgia"/>
+              </a:rPr>
+              <a:t>Vctrl</a:t>
+            </a:r>
+          </a:p>
+        </p:txBody>
+      </p:sp>
+      <p:cxnSp>
+        <p:nvCxnSpPr>
+          <p:cNvPr id="25" name="Connector 24"/>
+          <p:cNvCxnSpPr/>
+          <p:nvPr/>
+        </p:nvCxnSpPr>
+        <p:spPr>
+          <a:xfrm>
+            <a:off x="11064240" y="4114800"/>
+            <a:ext cx="0" cy="393192"/>
+          </a:xfrm>
+          <a:prstGeom prst="line">
+            <a:avLst/>
+          </a:prstGeom>
+          <a:ln w="15875">
+            <a:solidFill>
+              <a:srgbClr val="77716A"/>
+            </a:solidFill>
+            <a:tailEnd type="triangle" w="med" len="med"/>
           </a:ln>
         </p:spPr>
         <p:style>
@@ -4391,9 +4441,9 @@
           <p:nvPr/>
         </p:nvCxnSpPr>
         <p:spPr>
-          <a:xfrm flipV="1">
-            <a:off x="9235440" y="4133087"/>
-            <a:ext cx="0" cy="827533"/>
+          <a:xfrm>
+            <a:off x="7406640" y="2834639"/>
+            <a:ext cx="0" cy="393193"/>
           </a:xfrm>
           <a:prstGeom prst="line">
             <a:avLst/>
@@ -4427,9 +4477,9 @@
           <p:nvPr/>
         </p:nvCxnSpPr>
         <p:spPr>
-          <a:xfrm flipV="1">
-            <a:off x="9235440" y="3063239"/>
-            <a:ext cx="0" cy="182881"/>
+          <a:xfrm flipH="1">
+            <a:off x="9235440" y="4960620"/>
+            <a:ext cx="1097280" cy="0"/>
           </a:xfrm>
           <a:prstGeom prst="line">
             <a:avLst/>
@@ -4462,9 +4512,9 @@
           <p:nvPr/>
         </p:nvCxnSpPr>
         <p:spPr>
-          <a:xfrm flipH="1">
-            <a:off x="7726679" y="3063239"/>
-            <a:ext cx="1508761" cy="0"/>
+          <a:xfrm flipV="1">
+            <a:off x="9235440" y="4133087"/>
+            <a:ext cx="0" cy="827533"/>
           </a:xfrm>
           <a:prstGeom prst="line">
             <a:avLst/>
@@ -4473,6 +4523,7 @@
             <a:solidFill>
               <a:srgbClr val="77716A"/>
             </a:solidFill>
+            <a:tailEnd type="triangle" w="med" len="med"/>
           </a:ln>
         </p:spPr>
         <p:style>
@@ -4498,6 +4549,76 @@
         </p:nvCxnSpPr>
         <p:spPr>
           <a:xfrm flipV="1">
+            <a:off x="9235440" y="3063239"/>
+            <a:ext cx="0" cy="182881"/>
+          </a:xfrm>
+          <a:prstGeom prst="line">
+            <a:avLst/>
+          </a:prstGeom>
+          <a:ln w="15875">
+            <a:solidFill>
+              <a:srgbClr val="77716A"/>
+            </a:solidFill>
+          </a:ln>
+        </p:spPr>
+        <p:style>
+          <a:lnRef idx="2">
+            <a:schemeClr val="accent1"/>
+          </a:lnRef>
+          <a:fillRef idx="0">
+            <a:schemeClr val="accent1"/>
+          </a:fillRef>
+          <a:effectRef idx="1">
+            <a:schemeClr val="accent1"/>
+          </a:effectRef>
+          <a:fontRef idx="minor">
+            <a:schemeClr val="tx1"/>
+          </a:fontRef>
+        </p:style>
+      </p:cxnSp>
+      <p:cxnSp>
+        <p:nvCxnSpPr>
+          <p:cNvPr id="30" name="Connector 29"/>
+          <p:cNvCxnSpPr/>
+          <p:nvPr/>
+        </p:nvCxnSpPr>
+        <p:spPr>
+          <a:xfrm flipH="1">
+            <a:off x="7726679" y="3063239"/>
+            <a:ext cx="1508761" cy="0"/>
+          </a:xfrm>
+          <a:prstGeom prst="line">
+            <a:avLst/>
+          </a:prstGeom>
+          <a:ln w="15875">
+            <a:solidFill>
+              <a:srgbClr val="77716A"/>
+            </a:solidFill>
+          </a:ln>
+        </p:spPr>
+        <p:style>
+          <a:lnRef idx="2">
+            <a:schemeClr val="accent1"/>
+          </a:lnRef>
+          <a:fillRef idx="0">
+            <a:schemeClr val="accent1"/>
+          </a:fillRef>
+          <a:effectRef idx="1">
+            <a:schemeClr val="accent1"/>
+          </a:effectRef>
+          <a:fontRef idx="minor">
+            <a:schemeClr val="tx1"/>
+          </a:fontRef>
+        </p:style>
+      </p:cxnSp>
+      <p:cxnSp>
+        <p:nvCxnSpPr>
+          <p:cNvPr id="31" name="Connector 30"/>
+          <p:cNvCxnSpPr/>
+          <p:nvPr/>
+        </p:nvCxnSpPr>
+        <p:spPr>
+          <a:xfrm flipV="1">
             <a:off x="7726679" y="2852927"/>
             <a:ext cx="0" cy="210312"/>
           </a:xfrm>
@@ -4528,7 +4649,7 @@
       </p:cxnSp>
       <p:sp>
         <p:nvSpPr>
-          <p:cNvPr id="30" name="TextBox 29"/>
+          <p:cNvPr id="32" name="TextBox 31"/>
           <p:cNvSpPr txBox="1"/>
           <p:nvPr/>
         </p:nvSpPr>
@@ -4563,7 +4684,7 @@
       </p:sp>
       <p:sp>
         <p:nvSpPr>
-          <p:cNvPr id="31" name="Rectangle 30"/>
+          <p:cNvPr id="33" name="Rectangle 32"/>
           <p:cNvSpPr/>
           <p:nvPr/>
         </p:nvSpPr>
@@ -4609,7 +4730,7 @@
       </p:sp>
       <p:sp>
         <p:nvSpPr>
-          <p:cNvPr id="32" name="TextBox 31"/>
+          <p:cNvPr id="34" name="TextBox 33"/>
           <p:cNvSpPr txBox="1"/>
           <p:nvPr/>
         </p:nvSpPr>
@@ -4644,7 +4765,7 @@
       </p:sp>
       <p:sp>
         <p:nvSpPr>
-          <p:cNvPr id="33" name="Rectangle 32"/>
+          <p:cNvPr id="35" name="Rectangle 34"/>
           <p:cNvSpPr/>
           <p:nvPr/>
         </p:nvSpPr>
@@ -4690,7 +4811,7 @@
       </p:sp>
       <p:sp>
         <p:nvSpPr>
-          <p:cNvPr id="34" name="TextBox 33"/>
+          <p:cNvPr id="36" name="TextBox 35"/>
           <p:cNvSpPr txBox="1"/>
           <p:nvPr/>
         </p:nvSpPr>
@@ -4725,7 +4846,7 @@
       </p:sp>
       <p:sp>
         <p:nvSpPr>
-          <p:cNvPr id="35" name="Rectangle 34"/>
+          <p:cNvPr id="37" name="Rectangle 36"/>
           <p:cNvSpPr/>
           <p:nvPr/>
         </p:nvSpPr>
@@ -4771,7 +4892,7 @@
       </p:sp>
       <p:sp>
         <p:nvSpPr>
-          <p:cNvPr id="36" name="TextBox 35"/>
+          <p:cNvPr id="38" name="TextBox 37"/>
           <p:cNvSpPr txBox="1"/>
           <p:nvPr/>
         </p:nvSpPr>
@@ -4806,7 +4927,7 @@
       </p:sp>
       <p:sp>
         <p:nvSpPr>
-          <p:cNvPr id="37" name="Rectangle 36"/>
+          <p:cNvPr id="39" name="Rectangle 38"/>
           <p:cNvSpPr/>
           <p:nvPr/>
         </p:nvSpPr>
@@ -4852,7 +4973,7 @@
       </p:sp>
       <p:sp>
         <p:nvSpPr>
-          <p:cNvPr id="38" name="TextBox 37"/>
+          <p:cNvPr id="40" name="TextBox 39"/>
           <p:cNvSpPr txBox="1"/>
           <p:nvPr/>
         </p:nvSpPr>

</xml_diff>